<commit_message>
Rename to ContentHub and AP
</commit_message>
<xml_diff>
--- a/assets/figures.pptx
+++ b/assets/figures.pptx
@@ -250,7 +250,7 @@
           <a:p>
             <a:fld id="{C07B6569-5EFF-41A8-B6CB-39864A9A9501}" type="datetimeFigureOut">
               <a:rPr lang="de-DE" smtClean="0"/>
-              <a:t>24.01.2026</a:t>
+              <a:t>22.09.2026</a:t>
             </a:fld>
             <a:endParaRPr lang="de-DE"/>
           </a:p>
@@ -420,7 +420,7 @@
           <a:p>
             <a:fld id="{C07B6569-5EFF-41A8-B6CB-39864A9A9501}" type="datetimeFigureOut">
               <a:rPr lang="de-DE" smtClean="0"/>
-              <a:t>24.01.2026</a:t>
+              <a:t>22.09.2026</a:t>
             </a:fld>
             <a:endParaRPr lang="de-DE"/>
           </a:p>
@@ -600,7 +600,7 @@
           <a:p>
             <a:fld id="{C07B6569-5EFF-41A8-B6CB-39864A9A9501}" type="datetimeFigureOut">
               <a:rPr lang="de-DE" smtClean="0"/>
-              <a:t>24.01.2026</a:t>
+              <a:t>22.09.2026</a:t>
             </a:fld>
             <a:endParaRPr lang="de-DE"/>
           </a:p>
@@ -847,7 +847,7 @@
           <a:p>
             <a:fld id="{C07B6569-5EFF-41A8-B6CB-39864A9A9501}" type="datetimeFigureOut">
               <a:rPr lang="de-DE" smtClean="0"/>
-              <a:t>24.01.2026</a:t>
+              <a:t>22.09.2026</a:t>
             </a:fld>
             <a:endParaRPr lang="de-DE"/>
           </a:p>
@@ -1091,7 +1091,7 @@
           <a:p>
             <a:fld id="{C07B6569-5EFF-41A8-B6CB-39864A9A9501}" type="datetimeFigureOut">
               <a:rPr lang="de-DE" smtClean="0"/>
-              <a:t>24.01.2026</a:t>
+              <a:t>22.09.2026</a:t>
             </a:fld>
             <a:endParaRPr lang="de-DE"/>
           </a:p>
@@ -1323,7 +1323,7 @@
           <a:p>
             <a:fld id="{C07B6569-5EFF-41A8-B6CB-39864A9A9501}" type="datetimeFigureOut">
               <a:rPr lang="de-DE" smtClean="0"/>
-              <a:t>24.01.2026</a:t>
+              <a:t>22.09.2026</a:t>
             </a:fld>
             <a:endParaRPr lang="de-DE"/>
           </a:p>
@@ -1690,7 +1690,7 @@
           <a:p>
             <a:fld id="{C07B6569-5EFF-41A8-B6CB-39864A9A9501}" type="datetimeFigureOut">
               <a:rPr lang="de-DE" smtClean="0"/>
-              <a:t>24.01.2026</a:t>
+              <a:t>22.09.2026</a:t>
             </a:fld>
             <a:endParaRPr lang="de-DE"/>
           </a:p>
@@ -1808,7 +1808,7 @@
           <a:p>
             <a:fld id="{C07B6569-5EFF-41A8-B6CB-39864A9A9501}" type="datetimeFigureOut">
               <a:rPr lang="de-DE" smtClean="0"/>
-              <a:t>24.01.2026</a:t>
+              <a:t>22.09.2026</a:t>
             </a:fld>
             <a:endParaRPr lang="de-DE"/>
           </a:p>
@@ -1903,7 +1903,7 @@
           <a:p>
             <a:fld id="{C07B6569-5EFF-41A8-B6CB-39864A9A9501}" type="datetimeFigureOut">
               <a:rPr lang="de-DE" smtClean="0"/>
-              <a:t>24.01.2026</a:t>
+              <a:t>22.09.2026</a:t>
             </a:fld>
             <a:endParaRPr lang="de-DE"/>
           </a:p>
@@ -2180,7 +2180,7 @@
           <a:p>
             <a:fld id="{C07B6569-5EFF-41A8-B6CB-39864A9A9501}" type="datetimeFigureOut">
               <a:rPr lang="de-DE" smtClean="0"/>
-              <a:t>24.01.2026</a:t>
+              <a:t>22.09.2026</a:t>
             </a:fld>
             <a:endParaRPr lang="de-DE"/>
           </a:p>
@@ -2437,7 +2437,7 @@
           <a:p>
             <a:fld id="{C07B6569-5EFF-41A8-B6CB-39864A9A9501}" type="datetimeFigureOut">
               <a:rPr lang="de-DE" smtClean="0"/>
-              <a:t>24.01.2026</a:t>
+              <a:t>22.09.2026</a:t>
             </a:fld>
             <a:endParaRPr lang="de-DE"/>
           </a:p>
@@ -2650,7 +2650,7 @@
           <a:p>
             <a:fld id="{C07B6569-5EFF-41A8-B6CB-39864A9A9501}" type="datetimeFigureOut">
               <a:rPr lang="de-DE" smtClean="0"/>
-              <a:t>24.01.2026</a:t>
+              <a:t>22.09.2026</a:t>
             </a:fld>
             <a:endParaRPr lang="de-DE"/>
           </a:p>
@@ -4030,7 +4030,7 @@
                     <a:srgbClr val="405786"/>
                   </a:solidFill>
                 </a:rPr>
-                <a:t>Assessment Content Package</a:t>
+                <a:t>Assessment Package</a:t>
               </a:r>
             </a:p>
           </p:txBody>
@@ -4846,7 +4846,7 @@
               <a:pPr algn="ctr"/>
               <a:r>
                 <a:rPr lang="de-DE" sz="1200"/>
-                <a:t>IQB-ContentPool</a:t>
+                <a:t>IQB-ContentHub</a:t>
               </a:r>
             </a:p>
           </p:txBody>
@@ -6777,7 +6777,7 @@
         </p:nvSpPr>
         <p:spPr>
           <a:xfrm rot="5400000">
-            <a:off x="3279685" y="5262563"/>
+            <a:off x="3272541" y="5262563"/>
             <a:ext cx="581025" cy="161925"/>
           </a:xfrm>
           <a:prstGeom prst="rect">
@@ -7663,7 +7663,7 @@
                   <a:srgbClr val="405786"/>
                 </a:solidFill>
               </a:rPr>
-              <a:t>Assessment Content Package</a:t>
+              <a:t>Assessment Package</a:t>
             </a:r>
           </a:p>
           <a:p>
@@ -8038,7 +8038,7 @@
         </p:nvSpPr>
         <p:spPr>
           <a:xfrm>
-            <a:off x="3091261" y="5315827"/>
+            <a:off x="3268270" y="5303452"/>
             <a:ext cx="1294332" cy="443249"/>
           </a:xfrm>
           <a:prstGeom prst="rect">
@@ -8100,8 +8100,8 @@
         </p:nvSpPr>
         <p:spPr>
           <a:xfrm rot="16200000">
-            <a:off x="2439140" y="5534319"/>
-            <a:ext cx="873197" cy="317898"/>
+            <a:off x="2409548" y="5393561"/>
+            <a:ext cx="591680" cy="317898"/>
           </a:xfrm>
           <a:prstGeom prst="rightArrow">
             <a:avLst/>
@@ -8152,8 +8152,8 @@
         </p:nvSpPr>
         <p:spPr>
           <a:xfrm>
-            <a:off x="2418787" y="5705344"/>
-            <a:ext cx="912402" cy="465410"/>
+            <a:off x="2288938" y="5841478"/>
+            <a:ext cx="646609" cy="465410"/>
           </a:xfrm>
           <a:prstGeom prst="rect">
             <a:avLst/>
@@ -8191,6 +8191,120 @@
                 </a:solidFill>
               </a:rPr>
               <a:t>Zusatz-items</a:t>
+            </a:r>
+            <a:endParaRPr lang="de-DE" sz="1400">
+              <a:solidFill>
+                <a:srgbClr val="405786"/>
+              </a:solidFill>
+            </a:endParaRPr>
+          </a:p>
+        </p:txBody>
+      </p:sp>
+      <p:sp>
+        <p:nvSpPr>
+          <p:cNvPr id="29" name="Pfeil: nach rechts 28">
+            <a:extLst>
+              <a:ext uri="{FF2B5EF4-FFF2-40B4-BE49-F238E27FC236}">
+                <a16:creationId xmlns:a16="http://schemas.microsoft.com/office/drawing/2014/main" id="{2C84FA60-ECCB-4D17-813F-49C831BF79BD}"/>
+              </a:ext>
+            </a:extLst>
+          </p:cNvPr>
+          <p:cNvSpPr/>
+          <p:nvPr/>
+        </p:nvSpPr>
+        <p:spPr>
+          <a:xfrm rot="16200000">
+            <a:off x="2750597" y="5386689"/>
+            <a:ext cx="591680" cy="317898"/>
+          </a:xfrm>
+          <a:prstGeom prst="rightArrow">
+            <a:avLst/>
+          </a:prstGeom>
+          <a:solidFill>
+            <a:srgbClr val="D6DCE5"/>
+          </a:solidFill>
+          <a:ln>
+            <a:noFill/>
+          </a:ln>
+        </p:spPr>
+        <p:style>
+          <a:lnRef idx="2">
+            <a:schemeClr val="accent1">
+              <a:shade val="50000"/>
+            </a:schemeClr>
+          </a:lnRef>
+          <a:fillRef idx="1">
+            <a:schemeClr val="accent1"/>
+          </a:fillRef>
+          <a:effectRef idx="0">
+            <a:schemeClr val="accent1"/>
+          </a:effectRef>
+          <a:fontRef idx="minor">
+            <a:schemeClr val="lt1"/>
+          </a:fontRef>
+        </p:style>
+        <p:txBody>
+          <a:bodyPr rtlCol="0" anchor="ctr"/>
+          <a:lstStyle/>
+          <a:p>
+            <a:pPr algn="ctr"/>
+            <a:endParaRPr lang="de-DE"/>
+          </a:p>
+        </p:txBody>
+      </p:sp>
+      <p:sp>
+        <p:nvSpPr>
+          <p:cNvPr id="31" name="Rechteck 30">
+            <a:extLst>
+              <a:ext uri="{FF2B5EF4-FFF2-40B4-BE49-F238E27FC236}">
+                <a16:creationId xmlns:a16="http://schemas.microsoft.com/office/drawing/2014/main" id="{36DBFEC0-E32B-4C6A-895C-18974A3E5691}"/>
+              </a:ext>
+            </a:extLst>
+          </p:cNvPr>
+          <p:cNvSpPr/>
+          <p:nvPr/>
+        </p:nvSpPr>
+        <p:spPr>
+          <a:xfrm>
+            <a:off x="2798534" y="5841478"/>
+            <a:ext cx="806679" cy="465410"/>
+          </a:xfrm>
+          <a:prstGeom prst="rect">
+            <a:avLst/>
+          </a:prstGeom>
+          <a:noFill/>
+          <a:ln>
+            <a:noFill/>
+          </a:ln>
+        </p:spPr>
+        <p:style>
+          <a:lnRef idx="2">
+            <a:schemeClr val="accent1">
+              <a:shade val="50000"/>
+            </a:schemeClr>
+          </a:lnRef>
+          <a:fillRef idx="1">
+            <a:schemeClr val="accent1"/>
+          </a:fillRef>
+          <a:effectRef idx="0">
+            <a:schemeClr val="accent1"/>
+          </a:effectRef>
+          <a:fontRef idx="minor">
+            <a:schemeClr val="lt1"/>
+          </a:fontRef>
+        </p:style>
+        <p:txBody>
+          <a:bodyPr rtlCol="0" anchor="t"/>
+          <a:lstStyle/>
+          <a:p>
+            <a:pPr algn="ctr"/>
+            <a:r>
+              <a:rPr lang="de-DE" sz="1200">
+                <a:solidFill>
+                  <a:srgbClr val="405786"/>
+                </a:solidFill>
+              </a:rPr>
+              <a:t>Fähigkeitswerte aus Vorjahr</a:t>
             </a:r>
             <a:endParaRPr lang="de-DE" sz="1400">
               <a:solidFill>
@@ -9570,9 +9684,8 @@
             <a:pPr algn="ctr"/>
             <a:r>
               <a:rPr lang="de-DE" sz="1400"/>
-              <a:t>Assessment Content Pool</a:t>
-            </a:r>
-            <a:endParaRPr lang="de-DE"/>
+              <a:t>IQB-ContentHub</a:t>
+            </a:r>
           </a:p>
         </p:txBody>
       </p:sp>
@@ -9628,7 +9741,7 @@
                   <a:srgbClr val="405786"/>
                 </a:solidFill>
               </a:rPr>
-              <a:t>Content Package</a:t>
+              <a:t>Assessment Package</a:t>
             </a:r>
             <a:endParaRPr lang="de-DE" sz="1400">
               <a:solidFill>
@@ -10844,7 +10957,7 @@
             <a:pPr algn="ctr"/>
             <a:r>
               <a:rPr lang="de-DE" sz="1400"/>
-              <a:t>Assessment Content Pool</a:t>
+              <a:t>IQB-ContentHub</a:t>
             </a:r>
             <a:endParaRPr lang="de-DE"/>
           </a:p>
@@ -10902,7 +11015,7 @@
                   <a:srgbClr val="405786"/>
                 </a:solidFill>
               </a:rPr>
-              <a:t>Content Package</a:t>
+              <a:t>Assessment Package</a:t>
             </a:r>
             <a:endParaRPr lang="de-DE" sz="1400">
               <a:solidFill>

</xml_diff>

<commit_message>
Rename root to content-hub
</commit_message>
<xml_diff>
--- a/assets/figures.pptx
+++ b/assets/figures.pptx
@@ -13,6 +13,8 @@
     <p:sldId id="261" r:id="rId7"/>
     <p:sldId id="262" r:id="rId8"/>
     <p:sldId id="260" r:id="rId9"/>
+    <p:sldId id="265" r:id="rId10"/>
+    <p:sldId id="266" r:id="rId11"/>
   </p:sldIdLst>
   <p:sldSz cx="6858000" cy="9144000" type="screen4x3"/>
   <p:notesSz cx="6858000" cy="9144000"/>
@@ -250,7 +252,7 @@
           <a:p>
             <a:fld id="{C07B6569-5EFF-41A8-B6CB-39864A9A9501}" type="datetimeFigureOut">
               <a:rPr lang="de-DE" smtClean="0"/>
-              <a:t>22.09.2026</a:t>
+              <a:t>23.09.2026</a:t>
             </a:fld>
             <a:endParaRPr lang="de-DE"/>
           </a:p>
@@ -420,7 +422,7 @@
           <a:p>
             <a:fld id="{C07B6569-5EFF-41A8-B6CB-39864A9A9501}" type="datetimeFigureOut">
               <a:rPr lang="de-DE" smtClean="0"/>
-              <a:t>22.09.2026</a:t>
+              <a:t>23.09.2026</a:t>
             </a:fld>
             <a:endParaRPr lang="de-DE"/>
           </a:p>
@@ -600,7 +602,7 @@
           <a:p>
             <a:fld id="{C07B6569-5EFF-41A8-B6CB-39864A9A9501}" type="datetimeFigureOut">
               <a:rPr lang="de-DE" smtClean="0"/>
-              <a:t>22.09.2026</a:t>
+              <a:t>23.09.2026</a:t>
             </a:fld>
             <a:endParaRPr lang="de-DE"/>
           </a:p>
@@ -847,7 +849,7 @@
           <a:p>
             <a:fld id="{C07B6569-5EFF-41A8-B6CB-39864A9A9501}" type="datetimeFigureOut">
               <a:rPr lang="de-DE" smtClean="0"/>
-              <a:t>22.09.2026</a:t>
+              <a:t>23.09.2026</a:t>
             </a:fld>
             <a:endParaRPr lang="de-DE"/>
           </a:p>
@@ -1091,7 +1093,7 @@
           <a:p>
             <a:fld id="{C07B6569-5EFF-41A8-B6CB-39864A9A9501}" type="datetimeFigureOut">
               <a:rPr lang="de-DE" smtClean="0"/>
-              <a:t>22.09.2026</a:t>
+              <a:t>23.09.2026</a:t>
             </a:fld>
             <a:endParaRPr lang="de-DE"/>
           </a:p>
@@ -1323,7 +1325,7 @@
           <a:p>
             <a:fld id="{C07B6569-5EFF-41A8-B6CB-39864A9A9501}" type="datetimeFigureOut">
               <a:rPr lang="de-DE" smtClean="0"/>
-              <a:t>22.09.2026</a:t>
+              <a:t>23.09.2026</a:t>
             </a:fld>
             <a:endParaRPr lang="de-DE"/>
           </a:p>
@@ -1690,7 +1692,7 @@
           <a:p>
             <a:fld id="{C07B6569-5EFF-41A8-B6CB-39864A9A9501}" type="datetimeFigureOut">
               <a:rPr lang="de-DE" smtClean="0"/>
-              <a:t>22.09.2026</a:t>
+              <a:t>23.09.2026</a:t>
             </a:fld>
             <a:endParaRPr lang="de-DE"/>
           </a:p>
@@ -1808,7 +1810,7 @@
           <a:p>
             <a:fld id="{C07B6569-5EFF-41A8-B6CB-39864A9A9501}" type="datetimeFigureOut">
               <a:rPr lang="de-DE" smtClean="0"/>
-              <a:t>22.09.2026</a:t>
+              <a:t>23.09.2026</a:t>
             </a:fld>
             <a:endParaRPr lang="de-DE"/>
           </a:p>
@@ -1903,7 +1905,7 @@
           <a:p>
             <a:fld id="{C07B6569-5EFF-41A8-B6CB-39864A9A9501}" type="datetimeFigureOut">
               <a:rPr lang="de-DE" smtClean="0"/>
-              <a:t>22.09.2026</a:t>
+              <a:t>23.09.2026</a:t>
             </a:fld>
             <a:endParaRPr lang="de-DE"/>
           </a:p>
@@ -2180,7 +2182,7 @@
           <a:p>
             <a:fld id="{C07B6569-5EFF-41A8-B6CB-39864A9A9501}" type="datetimeFigureOut">
               <a:rPr lang="de-DE" smtClean="0"/>
-              <a:t>22.09.2026</a:t>
+              <a:t>23.09.2026</a:t>
             </a:fld>
             <a:endParaRPr lang="de-DE"/>
           </a:p>
@@ -2437,7 +2439,7 @@
           <a:p>
             <a:fld id="{C07B6569-5EFF-41A8-B6CB-39864A9A9501}" type="datetimeFigureOut">
               <a:rPr lang="de-DE" smtClean="0"/>
-              <a:t>22.09.2026</a:t>
+              <a:t>23.09.2026</a:t>
             </a:fld>
             <a:endParaRPr lang="de-DE"/>
           </a:p>
@@ -2650,7 +2652,7 @@
           <a:p>
             <a:fld id="{C07B6569-5EFF-41A8-B6CB-39864A9A9501}" type="datetimeFigureOut">
               <a:rPr lang="de-DE" smtClean="0"/>
-              <a:t>22.09.2026</a:t>
+              <a:t>23.09.2026</a:t>
             </a:fld>
             <a:endParaRPr lang="de-DE"/>
           </a:p>
@@ -3189,6 +3191,1276 @@
 </p:sld>
 </file>
 
+<file path=ppt/slides/slide10.xml><?xml version="1.0" encoding="utf-8"?>
+<p:sld xmlns:a="http://schemas.openxmlformats.org/drawingml/2006/main" xmlns:r="http://schemas.openxmlformats.org/officeDocument/2006/relationships" xmlns:p="http://schemas.openxmlformats.org/presentationml/2006/main">
+  <p:cSld>
+    <p:spTree>
+      <p:nvGrpSpPr>
+        <p:cNvPr id="1" name=""/>
+        <p:cNvGrpSpPr/>
+        <p:nvPr/>
+      </p:nvGrpSpPr>
+      <p:grpSpPr>
+        <a:xfrm>
+          <a:off x="0" y="0"/>
+          <a:ext cx="0" cy="0"/>
+          <a:chOff x="0" y="0"/>
+          <a:chExt cx="0" cy="0"/>
+        </a:xfrm>
+      </p:grpSpPr>
+      <p:sp>
+        <p:nvSpPr>
+          <p:cNvPr id="2" name="Titel 1">
+            <a:extLst>
+              <a:ext uri="{FF2B5EF4-FFF2-40B4-BE49-F238E27FC236}">
+                <a16:creationId xmlns:a16="http://schemas.microsoft.com/office/drawing/2014/main" id="{69664993-9ED6-4670-922B-6DCFB75DADAE}"/>
+              </a:ext>
+            </a:extLst>
+          </p:cNvPr>
+          <p:cNvSpPr>
+            <a:spLocks noGrp="1"/>
+          </p:cNvSpPr>
+          <p:nvPr>
+            <p:ph type="title"/>
+          </p:nvPr>
+        </p:nvSpPr>
+        <p:spPr/>
+        <p:txBody>
+          <a:bodyPr/>
+          <a:lstStyle/>
+          <a:p>
+            <a:r>
+              <a:rPr lang="de-DE"/>
+              <a:t>content-hub2.png</a:t>
+            </a:r>
+          </a:p>
+        </p:txBody>
+      </p:sp>
+      <p:sp>
+        <p:nvSpPr>
+          <p:cNvPr id="5" name="Rechteck 4">
+            <a:extLst>
+              <a:ext uri="{FF2B5EF4-FFF2-40B4-BE49-F238E27FC236}">
+                <a16:creationId xmlns:a16="http://schemas.microsoft.com/office/drawing/2014/main" id="{8D7D2D8F-2509-056B-8CAC-4F65CD4080E2}"/>
+              </a:ext>
+            </a:extLst>
+          </p:cNvPr>
+          <p:cNvSpPr/>
+          <p:nvPr/>
+        </p:nvSpPr>
+        <p:spPr>
+          <a:xfrm>
+            <a:off x="673103" y="2924124"/>
+            <a:ext cx="4787898" cy="2439086"/>
+          </a:xfrm>
+          <a:prstGeom prst="rect">
+            <a:avLst/>
+          </a:prstGeom>
+          <a:solidFill>
+            <a:srgbClr val="D6DCE5"/>
+          </a:solidFill>
+          <a:ln>
+            <a:noFill/>
+          </a:ln>
+        </p:spPr>
+        <p:style>
+          <a:lnRef idx="2">
+            <a:schemeClr val="accent1">
+              <a:shade val="50000"/>
+            </a:schemeClr>
+          </a:lnRef>
+          <a:fillRef idx="1">
+            <a:schemeClr val="accent1"/>
+          </a:fillRef>
+          <a:effectRef idx="0">
+            <a:schemeClr val="accent1"/>
+          </a:effectRef>
+          <a:fontRef idx="minor">
+            <a:schemeClr val="lt1"/>
+          </a:fontRef>
+        </p:style>
+        <p:txBody>
+          <a:bodyPr rtlCol="0" anchor="ctr"/>
+          <a:lstStyle/>
+          <a:p>
+            <a:endParaRPr lang="de-DE" sz="1600">
+              <a:solidFill>
+                <a:srgbClr val="405786"/>
+              </a:solidFill>
+            </a:endParaRPr>
+          </a:p>
+        </p:txBody>
+      </p:sp>
+      <p:cxnSp>
+        <p:nvCxnSpPr>
+          <p:cNvPr id="33" name="Gerade Verbindung mit Pfeil 32">
+            <a:extLst>
+              <a:ext uri="{FF2B5EF4-FFF2-40B4-BE49-F238E27FC236}">
+                <a16:creationId xmlns:a16="http://schemas.microsoft.com/office/drawing/2014/main" id="{0F9CB50D-6CAB-7433-6392-E47CC14FC637}"/>
+              </a:ext>
+            </a:extLst>
+          </p:cNvPr>
+          <p:cNvCxnSpPr>
+            <a:cxnSpLocks/>
+            <a:stCxn id="27" idx="0"/>
+            <a:endCxn id="37" idx="2"/>
+          </p:cNvCxnSpPr>
+          <p:nvPr/>
+        </p:nvCxnSpPr>
+        <p:spPr>
+          <a:xfrm flipH="1" flipV="1">
+            <a:off x="3807603" y="2819540"/>
+            <a:ext cx="1" cy="770227"/>
+          </a:xfrm>
+          <a:prstGeom prst="straightConnector1">
+            <a:avLst/>
+          </a:prstGeom>
+          <a:ln w="22225">
+            <a:solidFill>
+              <a:srgbClr val="405786"/>
+            </a:solidFill>
+            <a:headEnd type="arrow"/>
+            <a:tailEnd type="none"/>
+          </a:ln>
+        </p:spPr>
+        <p:style>
+          <a:lnRef idx="1">
+            <a:schemeClr val="accent1"/>
+          </a:lnRef>
+          <a:fillRef idx="0">
+            <a:schemeClr val="accent1"/>
+          </a:fillRef>
+          <a:effectRef idx="0">
+            <a:schemeClr val="accent1"/>
+          </a:effectRef>
+          <a:fontRef idx="minor">
+            <a:schemeClr val="tx1"/>
+          </a:fontRef>
+        </p:style>
+      </p:cxnSp>
+      <p:sp>
+        <p:nvSpPr>
+          <p:cNvPr id="37" name="Rechteck 36">
+            <a:extLst>
+              <a:ext uri="{FF2B5EF4-FFF2-40B4-BE49-F238E27FC236}">
+                <a16:creationId xmlns:a16="http://schemas.microsoft.com/office/drawing/2014/main" id="{6971455E-0E59-66A9-13C7-6EC0E700DC37}"/>
+              </a:ext>
+            </a:extLst>
+          </p:cNvPr>
+          <p:cNvSpPr/>
+          <p:nvPr/>
+        </p:nvSpPr>
+        <p:spPr>
+          <a:xfrm>
+            <a:off x="3374531" y="2525788"/>
+            <a:ext cx="866143" cy="293752"/>
+          </a:xfrm>
+          <a:prstGeom prst="rect">
+            <a:avLst/>
+          </a:prstGeom>
+          <a:noFill/>
+          <a:ln>
+            <a:noFill/>
+          </a:ln>
+        </p:spPr>
+        <p:style>
+          <a:lnRef idx="2">
+            <a:schemeClr val="accent1">
+              <a:shade val="50000"/>
+            </a:schemeClr>
+          </a:lnRef>
+          <a:fillRef idx="1">
+            <a:schemeClr val="accent1"/>
+          </a:fillRef>
+          <a:effectRef idx="0">
+            <a:schemeClr val="accent1"/>
+          </a:effectRef>
+          <a:fontRef idx="minor">
+            <a:schemeClr val="lt1"/>
+          </a:fontRef>
+        </p:style>
+        <p:txBody>
+          <a:bodyPr rtlCol="0" anchor="t"/>
+          <a:lstStyle/>
+          <a:p>
+            <a:pPr algn="ctr"/>
+            <a:r>
+              <a:rPr lang="de-DE" sz="1200">
+                <a:solidFill>
+                  <a:srgbClr val="405786"/>
+                </a:solidFill>
+              </a:rPr>
+              <a:t>eatTBA</a:t>
+            </a:r>
+            <a:endParaRPr lang="de-DE" sz="1400">
+              <a:solidFill>
+                <a:srgbClr val="405786"/>
+              </a:solidFill>
+            </a:endParaRPr>
+          </a:p>
+        </p:txBody>
+      </p:sp>
+      <p:cxnSp>
+        <p:nvCxnSpPr>
+          <p:cNvPr id="38" name="Gerade Verbindung mit Pfeil 37">
+            <a:extLst>
+              <a:ext uri="{FF2B5EF4-FFF2-40B4-BE49-F238E27FC236}">
+                <a16:creationId xmlns:a16="http://schemas.microsoft.com/office/drawing/2014/main" id="{1A197376-C3FE-BB86-D344-E3BF91183682}"/>
+              </a:ext>
+            </a:extLst>
+          </p:cNvPr>
+          <p:cNvCxnSpPr>
+            <a:cxnSpLocks/>
+            <a:stCxn id="44" idx="0"/>
+            <a:endCxn id="28" idx="3"/>
+          </p:cNvCxnSpPr>
+          <p:nvPr/>
+        </p:nvCxnSpPr>
+        <p:spPr>
+          <a:xfrm flipV="1">
+            <a:off x="4771593" y="4352771"/>
+            <a:ext cx="0" cy="1261899"/>
+          </a:xfrm>
+          <a:prstGeom prst="straightConnector1">
+            <a:avLst/>
+          </a:prstGeom>
+          <a:ln w="22225">
+            <a:solidFill>
+              <a:srgbClr val="405786"/>
+            </a:solidFill>
+            <a:headEnd type="arrow"/>
+            <a:tailEnd type="none"/>
+          </a:ln>
+        </p:spPr>
+        <p:style>
+          <a:lnRef idx="1">
+            <a:schemeClr val="accent1"/>
+          </a:lnRef>
+          <a:fillRef idx="0">
+            <a:schemeClr val="accent1"/>
+          </a:fillRef>
+          <a:effectRef idx="0">
+            <a:schemeClr val="accent1"/>
+          </a:effectRef>
+          <a:fontRef idx="minor">
+            <a:schemeClr val="tx1"/>
+          </a:fontRef>
+        </p:style>
+      </p:cxnSp>
+      <p:sp>
+        <p:nvSpPr>
+          <p:cNvPr id="44" name="Rechteck 43">
+            <a:extLst>
+              <a:ext uri="{FF2B5EF4-FFF2-40B4-BE49-F238E27FC236}">
+                <a16:creationId xmlns:a16="http://schemas.microsoft.com/office/drawing/2014/main" id="{E637A302-96ED-7826-494D-88887BBDE1C5}"/>
+              </a:ext>
+            </a:extLst>
+          </p:cNvPr>
+          <p:cNvSpPr/>
+          <p:nvPr/>
+        </p:nvSpPr>
+        <p:spPr>
+          <a:xfrm>
+            <a:off x="4338521" y="5614670"/>
+            <a:ext cx="866143" cy="690934"/>
+          </a:xfrm>
+          <a:prstGeom prst="rect">
+            <a:avLst/>
+          </a:prstGeom>
+          <a:noFill/>
+          <a:ln>
+            <a:noFill/>
+          </a:ln>
+        </p:spPr>
+        <p:style>
+          <a:lnRef idx="2">
+            <a:schemeClr val="accent1">
+              <a:shade val="50000"/>
+            </a:schemeClr>
+          </a:lnRef>
+          <a:fillRef idx="1">
+            <a:schemeClr val="accent1"/>
+          </a:fillRef>
+          <a:effectRef idx="0">
+            <a:schemeClr val="accent1"/>
+          </a:effectRef>
+          <a:fontRef idx="minor">
+            <a:schemeClr val="lt1"/>
+          </a:fontRef>
+        </p:style>
+        <p:txBody>
+          <a:bodyPr rtlCol="0" anchor="t"/>
+          <a:lstStyle/>
+          <a:p>
+            <a:pPr algn="ctr"/>
+            <a:r>
+              <a:rPr lang="de-DE" sz="1200">
+                <a:solidFill>
+                  <a:srgbClr val="405786"/>
+                </a:solidFill>
+              </a:rPr>
+              <a:t>Kodierbox, Testcenter, Studio</a:t>
+            </a:r>
+            <a:endParaRPr lang="de-DE" sz="1400">
+              <a:solidFill>
+                <a:srgbClr val="405786"/>
+              </a:solidFill>
+            </a:endParaRPr>
+          </a:p>
+        </p:txBody>
+      </p:sp>
+      <p:sp>
+        <p:nvSpPr>
+          <p:cNvPr id="45" name="Rechteck: abgerundete Ecken 44">
+            <a:extLst>
+              <a:ext uri="{FF2B5EF4-FFF2-40B4-BE49-F238E27FC236}">
+                <a16:creationId xmlns:a16="http://schemas.microsoft.com/office/drawing/2014/main" id="{21A32612-B86D-A65A-66E1-1FBC8117FB53}"/>
+              </a:ext>
+            </a:extLst>
+          </p:cNvPr>
+          <p:cNvSpPr/>
+          <p:nvPr/>
+        </p:nvSpPr>
+        <p:spPr>
+          <a:xfrm>
+            <a:off x="1563963" y="4754236"/>
+            <a:ext cx="1193748" cy="302977"/>
+          </a:xfrm>
+          <a:prstGeom prst="roundRect">
+            <a:avLst/>
+          </a:prstGeom>
+          <a:solidFill>
+            <a:srgbClr val="008CBA"/>
+          </a:solidFill>
+          <a:ln>
+            <a:noFill/>
+          </a:ln>
+        </p:spPr>
+        <p:style>
+          <a:lnRef idx="2">
+            <a:schemeClr val="accent1">
+              <a:shade val="50000"/>
+            </a:schemeClr>
+          </a:lnRef>
+          <a:fillRef idx="1">
+            <a:schemeClr val="accent1"/>
+          </a:fillRef>
+          <a:effectRef idx="0">
+            <a:schemeClr val="accent1"/>
+          </a:effectRef>
+          <a:fontRef idx="minor">
+            <a:schemeClr val="lt1"/>
+          </a:fontRef>
+        </p:style>
+        <p:txBody>
+          <a:bodyPr rtlCol="0" anchor="ctr"/>
+          <a:lstStyle/>
+          <a:p>
+            <a:pPr algn="ctr"/>
+            <a:r>
+              <a:rPr lang="de-DE" sz="1100"/>
+              <a:t>Booklet-Editor</a:t>
+            </a:r>
+            <a:endParaRPr lang="de-DE" sz="1400"/>
+          </a:p>
+        </p:txBody>
+      </p:sp>
+      <p:sp>
+        <p:nvSpPr>
+          <p:cNvPr id="46" name="Rechteck: abgerundete Ecken 45">
+            <a:extLst>
+              <a:ext uri="{FF2B5EF4-FFF2-40B4-BE49-F238E27FC236}">
+                <a16:creationId xmlns:a16="http://schemas.microsoft.com/office/drawing/2014/main" id="{7DC1F910-59AE-AD5E-9791-7FFB80DBF532}"/>
+              </a:ext>
+            </a:extLst>
+          </p:cNvPr>
+          <p:cNvSpPr/>
+          <p:nvPr/>
+        </p:nvSpPr>
+        <p:spPr>
+          <a:xfrm>
+            <a:off x="1563963" y="4403525"/>
+            <a:ext cx="1176563" cy="302977"/>
+          </a:xfrm>
+          <a:prstGeom prst="roundRect">
+            <a:avLst/>
+          </a:prstGeom>
+          <a:solidFill>
+            <a:srgbClr val="008CBA"/>
+          </a:solidFill>
+          <a:ln>
+            <a:noFill/>
+          </a:ln>
+        </p:spPr>
+        <p:style>
+          <a:lnRef idx="2">
+            <a:schemeClr val="accent1">
+              <a:shade val="50000"/>
+            </a:schemeClr>
+          </a:lnRef>
+          <a:fillRef idx="1">
+            <a:schemeClr val="accent1"/>
+          </a:fillRef>
+          <a:effectRef idx="0">
+            <a:schemeClr val="accent1"/>
+          </a:effectRef>
+          <a:fontRef idx="minor">
+            <a:schemeClr val="lt1"/>
+          </a:fontRef>
+        </p:style>
+        <p:txBody>
+          <a:bodyPr rtlCol="0" anchor="ctr"/>
+          <a:lstStyle/>
+          <a:p>
+            <a:pPr algn="ctr"/>
+            <a:r>
+              <a:rPr lang="de-DE" sz="1100"/>
+              <a:t>AP-Editor</a:t>
+            </a:r>
+            <a:endParaRPr lang="de-DE" sz="1400"/>
+          </a:p>
+        </p:txBody>
+      </p:sp>
+      <p:sp>
+        <p:nvSpPr>
+          <p:cNvPr id="47" name="Rechteck: abgerundete Ecken 46">
+            <a:extLst>
+              <a:ext uri="{FF2B5EF4-FFF2-40B4-BE49-F238E27FC236}">
+                <a16:creationId xmlns:a16="http://schemas.microsoft.com/office/drawing/2014/main" id="{596664A5-4892-9289-BFBE-354B0B2F0BC0}"/>
+              </a:ext>
+            </a:extLst>
+          </p:cNvPr>
+          <p:cNvSpPr/>
+          <p:nvPr/>
+        </p:nvSpPr>
+        <p:spPr>
+          <a:xfrm>
+            <a:off x="3515215" y="4403525"/>
+            <a:ext cx="1167661" cy="302977"/>
+          </a:xfrm>
+          <a:prstGeom prst="roundRect">
+            <a:avLst/>
+          </a:prstGeom>
+          <a:solidFill>
+            <a:srgbClr val="008CBA"/>
+          </a:solidFill>
+          <a:ln>
+            <a:noFill/>
+          </a:ln>
+        </p:spPr>
+        <p:style>
+          <a:lnRef idx="2">
+            <a:schemeClr val="accent1">
+              <a:shade val="50000"/>
+            </a:schemeClr>
+          </a:lnRef>
+          <a:fillRef idx="1">
+            <a:schemeClr val="accent1"/>
+          </a:fillRef>
+          <a:effectRef idx="0">
+            <a:schemeClr val="accent1"/>
+          </a:effectRef>
+          <a:fontRef idx="minor">
+            <a:schemeClr val="lt1"/>
+          </a:fontRef>
+        </p:style>
+        <p:txBody>
+          <a:bodyPr rtlCol="0" anchor="ctr"/>
+          <a:lstStyle/>
+          <a:p>
+            <a:pPr algn="ctr"/>
+            <a:r>
+              <a:rPr lang="de-DE" sz="1100"/>
+              <a:t>Item-Explorer</a:t>
+            </a:r>
+            <a:endParaRPr lang="de-DE" sz="1400"/>
+          </a:p>
+        </p:txBody>
+      </p:sp>
+      <p:cxnSp>
+        <p:nvCxnSpPr>
+          <p:cNvPr id="48" name="Gerade Verbindung mit Pfeil 47">
+            <a:extLst>
+              <a:ext uri="{FF2B5EF4-FFF2-40B4-BE49-F238E27FC236}">
+                <a16:creationId xmlns:a16="http://schemas.microsoft.com/office/drawing/2014/main" id="{8A6A495B-7CCF-28C4-22BE-4C6E2AF1E8DB}"/>
+              </a:ext>
+            </a:extLst>
+          </p:cNvPr>
+          <p:cNvCxnSpPr>
+            <a:cxnSpLocks/>
+            <a:stCxn id="28" idx="1"/>
+            <a:endCxn id="51" idx="2"/>
+          </p:cNvCxnSpPr>
+          <p:nvPr/>
+        </p:nvCxnSpPr>
+        <p:spPr>
+          <a:xfrm flipV="1">
+            <a:off x="4771593" y="2819540"/>
+            <a:ext cx="0" cy="590837"/>
+          </a:xfrm>
+          <a:prstGeom prst="straightConnector1">
+            <a:avLst/>
+          </a:prstGeom>
+          <a:ln w="22225">
+            <a:solidFill>
+              <a:srgbClr val="405786"/>
+            </a:solidFill>
+            <a:headEnd type="arrow"/>
+            <a:tailEnd type="none"/>
+          </a:ln>
+        </p:spPr>
+        <p:style>
+          <a:lnRef idx="1">
+            <a:schemeClr val="accent1"/>
+          </a:lnRef>
+          <a:fillRef idx="0">
+            <a:schemeClr val="accent1"/>
+          </a:fillRef>
+          <a:effectRef idx="0">
+            <a:schemeClr val="accent1"/>
+          </a:effectRef>
+          <a:fontRef idx="minor">
+            <a:schemeClr val="tx1"/>
+          </a:fontRef>
+        </p:style>
+      </p:cxnSp>
+      <p:sp>
+        <p:nvSpPr>
+          <p:cNvPr id="51" name="Rechteck 50">
+            <a:extLst>
+              <a:ext uri="{FF2B5EF4-FFF2-40B4-BE49-F238E27FC236}">
+                <a16:creationId xmlns:a16="http://schemas.microsoft.com/office/drawing/2014/main" id="{9294A9CF-27F9-37F4-0FF8-3C04FAA5328B}"/>
+              </a:ext>
+            </a:extLst>
+          </p:cNvPr>
+          <p:cNvSpPr/>
+          <p:nvPr/>
+        </p:nvSpPr>
+        <p:spPr>
+          <a:xfrm>
+            <a:off x="4338521" y="2525788"/>
+            <a:ext cx="866143" cy="293752"/>
+          </a:xfrm>
+          <a:prstGeom prst="rect">
+            <a:avLst/>
+          </a:prstGeom>
+          <a:noFill/>
+          <a:ln>
+            <a:noFill/>
+          </a:ln>
+        </p:spPr>
+        <p:style>
+          <a:lnRef idx="2">
+            <a:schemeClr val="accent1">
+              <a:shade val="50000"/>
+            </a:schemeClr>
+          </a:lnRef>
+          <a:fillRef idx="1">
+            <a:schemeClr val="accent1"/>
+          </a:fillRef>
+          <a:effectRef idx="0">
+            <a:schemeClr val="accent1"/>
+          </a:effectRef>
+          <a:fontRef idx="minor">
+            <a:schemeClr val="lt1"/>
+          </a:fontRef>
+        </p:style>
+        <p:txBody>
+          <a:bodyPr rtlCol="0" anchor="t"/>
+          <a:lstStyle/>
+          <a:p>
+            <a:pPr algn="ctr"/>
+            <a:r>
+              <a:rPr lang="de-DE" sz="1200">
+                <a:solidFill>
+                  <a:srgbClr val="405786"/>
+                </a:solidFill>
+              </a:rPr>
+              <a:t>Studio</a:t>
+            </a:r>
+            <a:endParaRPr lang="de-DE" sz="1400">
+              <a:solidFill>
+                <a:srgbClr val="405786"/>
+              </a:solidFill>
+            </a:endParaRPr>
+          </a:p>
+        </p:txBody>
+      </p:sp>
+      <p:sp>
+        <p:nvSpPr>
+          <p:cNvPr id="54" name="Rechteck: abgerundete Ecken 53">
+            <a:extLst>
+              <a:ext uri="{FF2B5EF4-FFF2-40B4-BE49-F238E27FC236}">
+                <a16:creationId xmlns:a16="http://schemas.microsoft.com/office/drawing/2014/main" id="{24E4B898-4F8E-7264-6EA6-7F4E96815992}"/>
+              </a:ext>
+            </a:extLst>
+          </p:cNvPr>
+          <p:cNvSpPr/>
+          <p:nvPr/>
+        </p:nvSpPr>
+        <p:spPr>
+          <a:xfrm>
+            <a:off x="3517692" y="4754236"/>
+            <a:ext cx="1167661" cy="302977"/>
+          </a:xfrm>
+          <a:prstGeom prst="roundRect">
+            <a:avLst/>
+          </a:prstGeom>
+          <a:solidFill>
+            <a:srgbClr val="008CBA"/>
+          </a:solidFill>
+          <a:ln>
+            <a:noFill/>
+          </a:ln>
+        </p:spPr>
+        <p:style>
+          <a:lnRef idx="2">
+            <a:schemeClr val="accent1">
+              <a:shade val="50000"/>
+            </a:schemeClr>
+          </a:lnRef>
+          <a:fillRef idx="1">
+            <a:schemeClr val="accent1"/>
+          </a:fillRef>
+          <a:effectRef idx="0">
+            <a:schemeClr val="accent1"/>
+          </a:effectRef>
+          <a:fontRef idx="minor">
+            <a:schemeClr val="lt1"/>
+          </a:fontRef>
+        </p:style>
+        <p:txBody>
+          <a:bodyPr rtlCol="0" anchor="ctr"/>
+          <a:lstStyle/>
+          <a:p>
+            <a:pPr algn="ctr"/>
+            <a:r>
+              <a:rPr lang="de-DE" sz="1100"/>
+              <a:t>Unit-Review</a:t>
+            </a:r>
+            <a:endParaRPr lang="de-DE" sz="1400"/>
+          </a:p>
+        </p:txBody>
+      </p:sp>
+      <p:cxnSp>
+        <p:nvCxnSpPr>
+          <p:cNvPr id="61" name="Gerade Verbindung mit Pfeil 60">
+            <a:extLst>
+              <a:ext uri="{FF2B5EF4-FFF2-40B4-BE49-F238E27FC236}">
+                <a16:creationId xmlns:a16="http://schemas.microsoft.com/office/drawing/2014/main" id="{EB18D02B-1379-4F64-B5ED-0A2795EF24CE}"/>
+              </a:ext>
+            </a:extLst>
+          </p:cNvPr>
+          <p:cNvCxnSpPr>
+            <a:cxnSpLocks/>
+            <a:stCxn id="62" idx="0"/>
+            <a:endCxn id="21" idx="3"/>
+          </p:cNvCxnSpPr>
+          <p:nvPr/>
+        </p:nvCxnSpPr>
+        <p:spPr>
+          <a:xfrm flipV="1">
+            <a:off x="2843613" y="4352771"/>
+            <a:ext cx="1" cy="1261899"/>
+          </a:xfrm>
+          <a:prstGeom prst="straightConnector1">
+            <a:avLst/>
+          </a:prstGeom>
+          <a:ln w="22225">
+            <a:solidFill>
+              <a:srgbClr val="405786"/>
+            </a:solidFill>
+            <a:headEnd type="arrow"/>
+            <a:tailEnd type="none"/>
+          </a:ln>
+        </p:spPr>
+        <p:style>
+          <a:lnRef idx="1">
+            <a:schemeClr val="accent1"/>
+          </a:lnRef>
+          <a:fillRef idx="0">
+            <a:schemeClr val="accent1"/>
+          </a:fillRef>
+          <a:effectRef idx="0">
+            <a:schemeClr val="accent1"/>
+          </a:effectRef>
+          <a:fontRef idx="minor">
+            <a:schemeClr val="tx1"/>
+          </a:fontRef>
+        </p:style>
+      </p:cxnSp>
+      <p:sp>
+        <p:nvSpPr>
+          <p:cNvPr id="62" name="Rechteck 61">
+            <a:extLst>
+              <a:ext uri="{FF2B5EF4-FFF2-40B4-BE49-F238E27FC236}">
+                <a16:creationId xmlns:a16="http://schemas.microsoft.com/office/drawing/2014/main" id="{CC41AD77-5AAA-106A-867F-605A09271D45}"/>
+              </a:ext>
+            </a:extLst>
+          </p:cNvPr>
+          <p:cNvSpPr/>
+          <p:nvPr/>
+        </p:nvSpPr>
+        <p:spPr>
+          <a:xfrm>
+            <a:off x="2410541" y="5614670"/>
+            <a:ext cx="866143" cy="373380"/>
+          </a:xfrm>
+          <a:prstGeom prst="rect">
+            <a:avLst/>
+          </a:prstGeom>
+          <a:noFill/>
+          <a:ln>
+            <a:noFill/>
+          </a:ln>
+        </p:spPr>
+        <p:style>
+          <a:lnRef idx="2">
+            <a:schemeClr val="accent1">
+              <a:shade val="50000"/>
+            </a:schemeClr>
+          </a:lnRef>
+          <a:fillRef idx="1">
+            <a:schemeClr val="accent1"/>
+          </a:fillRef>
+          <a:effectRef idx="0">
+            <a:schemeClr val="accent1"/>
+          </a:effectRef>
+          <a:fontRef idx="minor">
+            <a:schemeClr val="lt1"/>
+          </a:fontRef>
+        </p:style>
+        <p:txBody>
+          <a:bodyPr rtlCol="0" anchor="t"/>
+          <a:lstStyle/>
+          <a:p>
+            <a:pPr algn="ctr"/>
+            <a:r>
+              <a:rPr lang="de-DE" sz="1200">
+                <a:solidFill>
+                  <a:srgbClr val="405786"/>
+                </a:solidFill>
+              </a:rPr>
+              <a:t>Testcenter</a:t>
+            </a:r>
+            <a:endParaRPr lang="de-DE" sz="1400">
+              <a:solidFill>
+                <a:srgbClr val="405786"/>
+              </a:solidFill>
+            </a:endParaRPr>
+          </a:p>
+        </p:txBody>
+      </p:sp>
+      <p:sp>
+        <p:nvSpPr>
+          <p:cNvPr id="70" name="Pfeil: nach links 69">
+            <a:extLst>
+              <a:ext uri="{FF2B5EF4-FFF2-40B4-BE49-F238E27FC236}">
+                <a16:creationId xmlns:a16="http://schemas.microsoft.com/office/drawing/2014/main" id="{8B484C5C-6D69-9DC8-4FBC-0515C7CB2177}"/>
+              </a:ext>
+            </a:extLst>
+          </p:cNvPr>
+          <p:cNvSpPr/>
+          <p:nvPr/>
+        </p:nvSpPr>
+        <p:spPr>
+          <a:xfrm>
+            <a:off x="1926195" y="3730100"/>
+            <a:ext cx="2512455" cy="317898"/>
+          </a:xfrm>
+          <a:prstGeom prst="leftArrow">
+            <a:avLst/>
+          </a:prstGeom>
+          <a:solidFill>
+            <a:srgbClr val="405786"/>
+          </a:solidFill>
+          <a:ln>
+            <a:noFill/>
+          </a:ln>
+        </p:spPr>
+        <p:style>
+          <a:lnRef idx="2">
+            <a:schemeClr val="accent1">
+              <a:shade val="50000"/>
+            </a:schemeClr>
+          </a:lnRef>
+          <a:fillRef idx="1">
+            <a:schemeClr val="accent1"/>
+          </a:fillRef>
+          <a:effectRef idx="0">
+            <a:schemeClr val="accent1"/>
+          </a:effectRef>
+          <a:fontRef idx="minor">
+            <a:schemeClr val="lt1"/>
+          </a:fontRef>
+        </p:style>
+        <p:txBody>
+          <a:bodyPr rtlCol="0" anchor="ctr"/>
+          <a:lstStyle/>
+          <a:p>
+            <a:pPr algn="ctr"/>
+            <a:endParaRPr lang="de-DE"/>
+          </a:p>
+        </p:txBody>
+      </p:sp>
+      <p:sp>
+        <p:nvSpPr>
+          <p:cNvPr id="27" name="Rechteck: abgerundete Ecken 26">
+            <a:extLst>
+              <a:ext uri="{FF2B5EF4-FFF2-40B4-BE49-F238E27FC236}">
+                <a16:creationId xmlns:a16="http://schemas.microsoft.com/office/drawing/2014/main" id="{07071733-ACEA-D25D-4C7B-CD1FB7B4B6F5}"/>
+              </a:ext>
+            </a:extLst>
+          </p:cNvPr>
+          <p:cNvSpPr/>
+          <p:nvPr/>
+        </p:nvSpPr>
+        <p:spPr>
+          <a:xfrm>
+            <a:off x="3516161" y="3589767"/>
+            <a:ext cx="582885" cy="583615"/>
+          </a:xfrm>
+          <a:prstGeom prst="roundRect">
+            <a:avLst/>
+          </a:prstGeom>
+          <a:solidFill>
+            <a:srgbClr val="405786"/>
+          </a:solidFill>
+          <a:ln>
+            <a:solidFill>
+              <a:schemeClr val="bg1"/>
+            </a:solidFill>
+          </a:ln>
+        </p:spPr>
+        <p:style>
+          <a:lnRef idx="2">
+            <a:schemeClr val="accent1">
+              <a:shade val="50000"/>
+            </a:schemeClr>
+          </a:lnRef>
+          <a:fillRef idx="1">
+            <a:schemeClr val="accent1"/>
+          </a:fillRef>
+          <a:effectRef idx="0">
+            <a:schemeClr val="accent1"/>
+          </a:effectRef>
+          <a:fontRef idx="minor">
+            <a:schemeClr val="lt1"/>
+          </a:fontRef>
+        </p:style>
+        <p:txBody>
+          <a:bodyPr rtlCol="0" anchor="ctr"/>
+          <a:lstStyle/>
+          <a:p>
+            <a:pPr algn="ctr"/>
+            <a:r>
+              <a:rPr lang="de-DE" sz="1100"/>
+              <a:t>Item-kenn-werte</a:t>
+            </a:r>
+          </a:p>
+        </p:txBody>
+      </p:sp>
+      <p:sp>
+        <p:nvSpPr>
+          <p:cNvPr id="28" name="Flussdiagramm: Magnetplattenspeicher 27">
+            <a:extLst>
+              <a:ext uri="{FF2B5EF4-FFF2-40B4-BE49-F238E27FC236}">
+                <a16:creationId xmlns:a16="http://schemas.microsoft.com/office/drawing/2014/main" id="{4B77E6B9-BC69-0818-2754-F74A06B8E155}"/>
+              </a:ext>
+            </a:extLst>
+          </p:cNvPr>
+          <p:cNvSpPr/>
+          <p:nvPr/>
+        </p:nvSpPr>
+        <p:spPr>
+          <a:xfrm>
+            <a:off x="4266312" y="3410377"/>
+            <a:ext cx="1010561" cy="942394"/>
+          </a:xfrm>
+          <a:prstGeom prst="flowChartMagneticDisk">
+            <a:avLst/>
+          </a:prstGeom>
+          <a:solidFill>
+            <a:srgbClr val="405786"/>
+          </a:solidFill>
+          <a:ln>
+            <a:solidFill>
+              <a:schemeClr val="bg1"/>
+            </a:solidFill>
+          </a:ln>
+        </p:spPr>
+        <p:style>
+          <a:lnRef idx="2">
+            <a:schemeClr val="accent1">
+              <a:shade val="50000"/>
+            </a:schemeClr>
+          </a:lnRef>
+          <a:fillRef idx="1">
+            <a:schemeClr val="accent1"/>
+          </a:fillRef>
+          <a:effectRef idx="0">
+            <a:schemeClr val="accent1"/>
+          </a:effectRef>
+          <a:fontRef idx="minor">
+            <a:schemeClr val="lt1"/>
+          </a:fontRef>
+        </p:style>
+        <p:txBody>
+          <a:bodyPr rtlCol="0" anchor="ctr"/>
+          <a:lstStyle/>
+          <a:p>
+            <a:pPr algn="ctr"/>
+            <a:r>
+              <a:rPr lang="de-DE" sz="1400"/>
+              <a:t>Units</a:t>
+            </a:r>
+          </a:p>
+        </p:txBody>
+      </p:sp>
+      <p:sp>
+        <p:nvSpPr>
+          <p:cNvPr id="21" name="Flussdiagramm: Magnetplattenspeicher 20">
+            <a:extLst>
+              <a:ext uri="{FF2B5EF4-FFF2-40B4-BE49-F238E27FC236}">
+                <a16:creationId xmlns:a16="http://schemas.microsoft.com/office/drawing/2014/main" id="{C32C1D49-7C7A-B993-42CA-0EED9CF1F2A4}"/>
+              </a:ext>
+            </a:extLst>
+          </p:cNvPr>
+          <p:cNvSpPr/>
+          <p:nvPr/>
+        </p:nvSpPr>
+        <p:spPr>
+          <a:xfrm>
+            <a:off x="2338333" y="3410377"/>
+            <a:ext cx="1010561" cy="942394"/>
+          </a:xfrm>
+          <a:prstGeom prst="flowChartMagneticDisk">
+            <a:avLst/>
+          </a:prstGeom>
+          <a:solidFill>
+            <a:srgbClr val="405786"/>
+          </a:solidFill>
+          <a:ln>
+            <a:solidFill>
+              <a:schemeClr val="bg1"/>
+            </a:solidFill>
+          </a:ln>
+        </p:spPr>
+        <p:style>
+          <a:lnRef idx="2">
+            <a:schemeClr val="accent1">
+              <a:shade val="50000"/>
+            </a:schemeClr>
+          </a:lnRef>
+          <a:fillRef idx="1">
+            <a:schemeClr val="accent1"/>
+          </a:fillRef>
+          <a:effectRef idx="0">
+            <a:schemeClr val="accent1"/>
+          </a:effectRef>
+          <a:fontRef idx="minor">
+            <a:schemeClr val="lt1"/>
+          </a:fontRef>
+        </p:style>
+        <p:txBody>
+          <a:bodyPr rtlCol="0" anchor="ctr"/>
+          <a:lstStyle/>
+          <a:p>
+            <a:pPr algn="ctr"/>
+            <a:r>
+              <a:rPr lang="de-DE" sz="1400"/>
+              <a:t>Studien</a:t>
+            </a:r>
+          </a:p>
+        </p:txBody>
+      </p:sp>
+      <p:sp>
+        <p:nvSpPr>
+          <p:cNvPr id="69" name="Flussdiagramm: Magnetplattenspeicher 68">
+            <a:extLst>
+              <a:ext uri="{FF2B5EF4-FFF2-40B4-BE49-F238E27FC236}">
+                <a16:creationId xmlns:a16="http://schemas.microsoft.com/office/drawing/2014/main" id="{DDE9446D-D51E-2904-B43D-185315EA8514}"/>
+              </a:ext>
+            </a:extLst>
+          </p:cNvPr>
+          <p:cNvSpPr/>
+          <p:nvPr/>
+        </p:nvSpPr>
+        <p:spPr>
+          <a:xfrm>
+            <a:off x="915634" y="3408839"/>
+            <a:ext cx="1010561" cy="942394"/>
+          </a:xfrm>
+          <a:prstGeom prst="flowChartMagneticDisk">
+            <a:avLst/>
+          </a:prstGeom>
+          <a:solidFill>
+            <a:srgbClr val="405786"/>
+          </a:solidFill>
+          <a:ln>
+            <a:solidFill>
+              <a:schemeClr val="bg1"/>
+            </a:solidFill>
+          </a:ln>
+        </p:spPr>
+        <p:style>
+          <a:lnRef idx="2">
+            <a:schemeClr val="accent1">
+              <a:shade val="50000"/>
+            </a:schemeClr>
+          </a:lnRef>
+          <a:fillRef idx="1">
+            <a:schemeClr val="accent1"/>
+          </a:fillRef>
+          <a:effectRef idx="0">
+            <a:schemeClr val="accent1"/>
+          </a:effectRef>
+          <a:fontRef idx="minor">
+            <a:schemeClr val="lt1"/>
+          </a:fontRef>
+        </p:style>
+        <p:txBody>
+          <a:bodyPr rtlCol="0" anchor="ctr"/>
+          <a:lstStyle/>
+          <a:p>
+            <a:pPr algn="ctr"/>
+            <a:r>
+              <a:rPr lang="de-DE" sz="1200"/>
+              <a:t>Assessment Packages</a:t>
+            </a:r>
+          </a:p>
+        </p:txBody>
+      </p:sp>
+      <p:cxnSp>
+        <p:nvCxnSpPr>
+          <p:cNvPr id="71" name="Gerade Verbindung mit Pfeil 70">
+            <a:extLst>
+              <a:ext uri="{FF2B5EF4-FFF2-40B4-BE49-F238E27FC236}">
+                <a16:creationId xmlns:a16="http://schemas.microsoft.com/office/drawing/2014/main" id="{B0D7C2BE-8198-3335-8B85-FC4C9BA222D0}"/>
+              </a:ext>
+            </a:extLst>
+          </p:cNvPr>
+          <p:cNvCxnSpPr>
+            <a:cxnSpLocks/>
+            <a:endCxn id="69" idx="3"/>
+          </p:cNvCxnSpPr>
+          <p:nvPr/>
+        </p:nvCxnSpPr>
+        <p:spPr>
+          <a:xfrm flipV="1">
+            <a:off x="1420913" y="4351233"/>
+            <a:ext cx="2" cy="1267247"/>
+          </a:xfrm>
+          <a:prstGeom prst="straightConnector1">
+            <a:avLst/>
+          </a:prstGeom>
+          <a:ln w="22225">
+            <a:solidFill>
+              <a:srgbClr val="405786"/>
+            </a:solidFill>
+            <a:headEnd type="arrow"/>
+            <a:tailEnd type="none"/>
+          </a:ln>
+        </p:spPr>
+        <p:style>
+          <a:lnRef idx="1">
+            <a:schemeClr val="accent1"/>
+          </a:lnRef>
+          <a:fillRef idx="0">
+            <a:schemeClr val="accent1"/>
+          </a:fillRef>
+          <a:effectRef idx="0">
+            <a:schemeClr val="accent1"/>
+          </a:effectRef>
+          <a:fontRef idx="minor">
+            <a:schemeClr val="tx1"/>
+          </a:fontRef>
+        </p:style>
+      </p:cxnSp>
+      <p:sp>
+        <p:nvSpPr>
+          <p:cNvPr id="73" name="Rechteck 72">
+            <a:extLst>
+              <a:ext uri="{FF2B5EF4-FFF2-40B4-BE49-F238E27FC236}">
+                <a16:creationId xmlns:a16="http://schemas.microsoft.com/office/drawing/2014/main" id="{CD3FFE20-A974-9AD0-A923-EF18E789FC30}"/>
+              </a:ext>
+            </a:extLst>
+          </p:cNvPr>
+          <p:cNvSpPr/>
+          <p:nvPr/>
+        </p:nvSpPr>
+        <p:spPr>
+          <a:xfrm>
+            <a:off x="987841" y="5614670"/>
+            <a:ext cx="866143" cy="373380"/>
+          </a:xfrm>
+          <a:prstGeom prst="rect">
+            <a:avLst/>
+          </a:prstGeom>
+          <a:noFill/>
+          <a:ln>
+            <a:noFill/>
+          </a:ln>
+        </p:spPr>
+        <p:style>
+          <a:lnRef idx="2">
+            <a:schemeClr val="accent1">
+              <a:shade val="50000"/>
+            </a:schemeClr>
+          </a:lnRef>
+          <a:fillRef idx="1">
+            <a:schemeClr val="accent1"/>
+          </a:fillRef>
+          <a:effectRef idx="0">
+            <a:schemeClr val="accent1"/>
+          </a:effectRef>
+          <a:fontRef idx="minor">
+            <a:schemeClr val="lt1"/>
+          </a:fontRef>
+        </p:style>
+        <p:txBody>
+          <a:bodyPr rtlCol="0" anchor="t"/>
+          <a:lstStyle/>
+          <a:p>
+            <a:pPr algn="ctr"/>
+            <a:r>
+              <a:rPr lang="de-DE" sz="1200">
+                <a:solidFill>
+                  <a:srgbClr val="405786"/>
+                </a:solidFill>
+              </a:rPr>
+              <a:t>Länder</a:t>
+            </a:r>
+            <a:endParaRPr lang="de-DE" sz="1400">
+              <a:solidFill>
+                <a:srgbClr val="405786"/>
+              </a:solidFill>
+            </a:endParaRPr>
+          </a:p>
+        </p:txBody>
+      </p:sp>
+      <p:cxnSp>
+        <p:nvCxnSpPr>
+          <p:cNvPr id="74" name="Gerade Verbindung mit Pfeil 73">
+            <a:extLst>
+              <a:ext uri="{FF2B5EF4-FFF2-40B4-BE49-F238E27FC236}">
+                <a16:creationId xmlns:a16="http://schemas.microsoft.com/office/drawing/2014/main" id="{60D643AA-B387-867F-4232-15BF303F53C3}"/>
+              </a:ext>
+            </a:extLst>
+          </p:cNvPr>
+          <p:cNvCxnSpPr>
+            <a:cxnSpLocks/>
+            <a:stCxn id="21" idx="1"/>
+            <a:endCxn id="76" idx="2"/>
+          </p:cNvCxnSpPr>
+          <p:nvPr/>
+        </p:nvCxnSpPr>
+        <p:spPr>
+          <a:xfrm flipH="1" flipV="1">
+            <a:off x="2843613" y="2813963"/>
+            <a:ext cx="1" cy="596414"/>
+          </a:xfrm>
+          <a:prstGeom prst="straightConnector1">
+            <a:avLst/>
+          </a:prstGeom>
+          <a:ln w="22225">
+            <a:solidFill>
+              <a:srgbClr val="405786"/>
+            </a:solidFill>
+            <a:headEnd type="arrow"/>
+            <a:tailEnd type="none"/>
+          </a:ln>
+        </p:spPr>
+        <p:style>
+          <a:lnRef idx="1">
+            <a:schemeClr val="accent1"/>
+          </a:lnRef>
+          <a:fillRef idx="0">
+            <a:schemeClr val="accent1"/>
+          </a:fillRef>
+          <a:effectRef idx="0">
+            <a:schemeClr val="accent1"/>
+          </a:effectRef>
+          <a:fontRef idx="minor">
+            <a:schemeClr val="tx1"/>
+          </a:fontRef>
+        </p:style>
+      </p:cxnSp>
+      <p:sp>
+        <p:nvSpPr>
+          <p:cNvPr id="76" name="Rechteck 75">
+            <a:extLst>
+              <a:ext uri="{FF2B5EF4-FFF2-40B4-BE49-F238E27FC236}">
+                <a16:creationId xmlns:a16="http://schemas.microsoft.com/office/drawing/2014/main" id="{BE383267-29A9-9FC8-CE21-694445340630}"/>
+              </a:ext>
+            </a:extLst>
+          </p:cNvPr>
+          <p:cNvSpPr/>
+          <p:nvPr/>
+        </p:nvSpPr>
+        <p:spPr>
+          <a:xfrm>
+            <a:off x="2410541" y="2399938"/>
+            <a:ext cx="866143" cy="414025"/>
+          </a:xfrm>
+          <a:prstGeom prst="rect">
+            <a:avLst/>
+          </a:prstGeom>
+          <a:noFill/>
+          <a:ln>
+            <a:noFill/>
+          </a:ln>
+        </p:spPr>
+        <p:style>
+          <a:lnRef idx="2">
+            <a:schemeClr val="accent1">
+              <a:shade val="50000"/>
+            </a:schemeClr>
+          </a:lnRef>
+          <a:fillRef idx="1">
+            <a:schemeClr val="accent1"/>
+          </a:fillRef>
+          <a:effectRef idx="0">
+            <a:schemeClr val="accent1"/>
+          </a:effectRef>
+          <a:fontRef idx="minor">
+            <a:schemeClr val="lt1"/>
+          </a:fontRef>
+        </p:style>
+        <p:txBody>
+          <a:bodyPr rtlCol="0" anchor="t"/>
+          <a:lstStyle/>
+          <a:p>
+            <a:pPr algn="ctr"/>
+            <a:r>
+              <a:rPr lang="de-DE" sz="1200">
+                <a:solidFill>
+                  <a:srgbClr val="405786"/>
+                </a:solidFill>
+              </a:rPr>
+              <a:t>AP andere Quellen</a:t>
+            </a:r>
+            <a:endParaRPr lang="de-DE" sz="1400">
+              <a:solidFill>
+                <a:srgbClr val="405786"/>
+              </a:solidFill>
+            </a:endParaRPr>
+          </a:p>
+        </p:txBody>
+      </p:sp>
+    </p:spTree>
+    <p:extLst>
+      <p:ext uri="{BB962C8B-B14F-4D97-AF65-F5344CB8AC3E}">
+        <p14:creationId xmlns:p14="http://schemas.microsoft.com/office/powerpoint/2010/main" val="383421129"/>
+      </p:ext>
+    </p:extLst>
+  </p:cSld>
+  <p:clrMapOvr>
+    <a:masterClrMapping/>
+  </p:clrMapOvr>
+</p:sld>
+</file>
+
 <file path=ppt/slides/slide2.xml><?xml version="1.0" encoding="utf-8"?>
 <p:sld xmlns:a="http://schemas.openxmlformats.org/drawingml/2006/main" xmlns:r="http://schemas.openxmlformats.org/officeDocument/2006/relationships" xmlns:p="http://schemas.openxmlformats.org/presentationml/2006/main">
   <p:cSld>
@@ -10921,7 +12193,7 @@
         </p:nvSpPr>
         <p:spPr>
           <a:xfrm>
-            <a:off x="565608" y="2128711"/>
+            <a:off x="565608" y="2136331"/>
             <a:ext cx="1952967" cy="566909"/>
           </a:xfrm>
           <a:prstGeom prst="roundRect">
@@ -12613,6 +13885,1499 @@
     <p:extLst>
       <p:ext uri="{BB962C8B-B14F-4D97-AF65-F5344CB8AC3E}">
         <p14:creationId xmlns:p14="http://schemas.microsoft.com/office/powerpoint/2010/main" val="3091731184"/>
+      </p:ext>
+    </p:extLst>
+  </p:cSld>
+  <p:clrMapOvr>
+    <a:masterClrMapping/>
+  </p:clrMapOvr>
+</p:sld>
+</file>
+
+<file path=ppt/slides/slide9.xml><?xml version="1.0" encoding="utf-8"?>
+<p:sld xmlns:a="http://schemas.openxmlformats.org/drawingml/2006/main" xmlns:r="http://schemas.openxmlformats.org/officeDocument/2006/relationships" xmlns:p="http://schemas.openxmlformats.org/presentationml/2006/main">
+  <p:cSld>
+    <p:spTree>
+      <p:nvGrpSpPr>
+        <p:cNvPr id="1" name=""/>
+        <p:cNvGrpSpPr/>
+        <p:nvPr/>
+      </p:nvGrpSpPr>
+      <p:grpSpPr>
+        <a:xfrm>
+          <a:off x="0" y="0"/>
+          <a:ext cx="0" cy="0"/>
+          <a:chOff x="0" y="0"/>
+          <a:chExt cx="0" cy="0"/>
+        </a:xfrm>
+      </p:grpSpPr>
+      <p:sp>
+        <p:nvSpPr>
+          <p:cNvPr id="11" name="Pfeil: nach links und rechts 10">
+            <a:extLst>
+              <a:ext uri="{FF2B5EF4-FFF2-40B4-BE49-F238E27FC236}">
+                <a16:creationId xmlns:a16="http://schemas.microsoft.com/office/drawing/2014/main" id="{B373BB0E-CC21-4468-A11B-DA3B56985F35}"/>
+              </a:ext>
+            </a:extLst>
+          </p:cNvPr>
+          <p:cNvSpPr/>
+          <p:nvPr/>
+        </p:nvSpPr>
+        <p:spPr>
+          <a:xfrm rot="3850881">
+            <a:off x="1968300" y="2627138"/>
+            <a:ext cx="933542" cy="317898"/>
+          </a:xfrm>
+          <a:prstGeom prst="leftRightArrow">
+            <a:avLst/>
+          </a:prstGeom>
+          <a:solidFill>
+            <a:srgbClr val="D6DCE5"/>
+          </a:solidFill>
+          <a:ln>
+            <a:noFill/>
+          </a:ln>
+        </p:spPr>
+        <p:style>
+          <a:lnRef idx="2">
+            <a:schemeClr val="accent1">
+              <a:shade val="50000"/>
+            </a:schemeClr>
+          </a:lnRef>
+          <a:fillRef idx="1">
+            <a:schemeClr val="accent1"/>
+          </a:fillRef>
+          <a:effectRef idx="0">
+            <a:schemeClr val="accent1"/>
+          </a:effectRef>
+          <a:fontRef idx="minor">
+            <a:schemeClr val="lt1"/>
+          </a:fontRef>
+        </p:style>
+        <p:txBody>
+          <a:bodyPr rtlCol="0" anchor="ctr"/>
+          <a:lstStyle/>
+          <a:p>
+            <a:pPr algn="ctr"/>
+            <a:endParaRPr lang="de-DE"/>
+          </a:p>
+        </p:txBody>
+      </p:sp>
+      <p:sp>
+        <p:nvSpPr>
+          <p:cNvPr id="2" name="Titel 1">
+            <a:extLst>
+              <a:ext uri="{FF2B5EF4-FFF2-40B4-BE49-F238E27FC236}">
+                <a16:creationId xmlns:a16="http://schemas.microsoft.com/office/drawing/2014/main" id="{69664993-9ED6-4670-922B-6DCFB75DADAE}"/>
+              </a:ext>
+            </a:extLst>
+          </p:cNvPr>
+          <p:cNvSpPr>
+            <a:spLocks noGrp="1"/>
+          </p:cNvSpPr>
+          <p:nvPr>
+            <p:ph type="title"/>
+          </p:nvPr>
+        </p:nvSpPr>
+        <p:spPr/>
+        <p:txBody>
+          <a:bodyPr/>
+          <a:lstStyle/>
+          <a:p>
+            <a:r>
+              <a:rPr lang="de-DE"/>
+              <a:t>content-hub1.png</a:t>
+            </a:r>
+          </a:p>
+        </p:txBody>
+      </p:sp>
+      <p:sp>
+        <p:nvSpPr>
+          <p:cNvPr id="10" name="Rechteck 9">
+            <a:extLst>
+              <a:ext uri="{FF2B5EF4-FFF2-40B4-BE49-F238E27FC236}">
+                <a16:creationId xmlns:a16="http://schemas.microsoft.com/office/drawing/2014/main" id="{719FAA75-2688-4E1B-A8A9-97CF000C9D32}"/>
+              </a:ext>
+            </a:extLst>
+          </p:cNvPr>
+          <p:cNvSpPr/>
+          <p:nvPr/>
+        </p:nvSpPr>
+        <p:spPr>
+          <a:xfrm>
+            <a:off x="1868815" y="2604283"/>
+            <a:ext cx="912402" cy="256528"/>
+          </a:xfrm>
+          <a:prstGeom prst="rect">
+            <a:avLst/>
+          </a:prstGeom>
+          <a:noFill/>
+          <a:ln>
+            <a:noFill/>
+          </a:ln>
+        </p:spPr>
+        <p:style>
+          <a:lnRef idx="2">
+            <a:schemeClr val="accent1">
+              <a:shade val="50000"/>
+            </a:schemeClr>
+          </a:lnRef>
+          <a:fillRef idx="1">
+            <a:schemeClr val="accent1"/>
+          </a:fillRef>
+          <a:effectRef idx="0">
+            <a:schemeClr val="accent1"/>
+          </a:effectRef>
+          <a:fontRef idx="minor">
+            <a:schemeClr val="lt1"/>
+          </a:fontRef>
+        </p:style>
+        <p:txBody>
+          <a:bodyPr rtlCol="0" anchor="t"/>
+          <a:lstStyle/>
+          <a:p>
+            <a:pPr algn="ctr"/>
+            <a:r>
+              <a:rPr lang="de-DE" sz="1200">
+                <a:solidFill>
+                  <a:srgbClr val="405786"/>
+                </a:solidFill>
+              </a:rPr>
+              <a:t>Aufgaben</a:t>
+            </a:r>
+            <a:endParaRPr lang="de-DE" sz="1400">
+              <a:solidFill>
+                <a:srgbClr val="405786"/>
+              </a:solidFill>
+            </a:endParaRPr>
+          </a:p>
+        </p:txBody>
+      </p:sp>
+      <p:sp>
+        <p:nvSpPr>
+          <p:cNvPr id="22" name="Pfeil: nach rechts 21">
+            <a:extLst>
+              <a:ext uri="{FF2B5EF4-FFF2-40B4-BE49-F238E27FC236}">
+                <a16:creationId xmlns:a16="http://schemas.microsoft.com/office/drawing/2014/main" id="{F0ED9A78-65FF-4184-87C8-D2B65CA89911}"/>
+              </a:ext>
+            </a:extLst>
+          </p:cNvPr>
+          <p:cNvSpPr/>
+          <p:nvPr/>
+        </p:nvSpPr>
+        <p:spPr>
+          <a:xfrm>
+            <a:off x="2435072" y="5342284"/>
+            <a:ext cx="1349261" cy="317898"/>
+          </a:xfrm>
+          <a:prstGeom prst="rightArrow">
+            <a:avLst/>
+          </a:prstGeom>
+          <a:solidFill>
+            <a:srgbClr val="D6DCE5"/>
+          </a:solidFill>
+          <a:ln>
+            <a:noFill/>
+          </a:ln>
+        </p:spPr>
+        <p:style>
+          <a:lnRef idx="2">
+            <a:schemeClr val="accent1">
+              <a:shade val="50000"/>
+            </a:schemeClr>
+          </a:lnRef>
+          <a:fillRef idx="1">
+            <a:schemeClr val="accent1"/>
+          </a:fillRef>
+          <a:effectRef idx="0">
+            <a:schemeClr val="accent1"/>
+          </a:effectRef>
+          <a:fontRef idx="minor">
+            <a:schemeClr val="lt1"/>
+          </a:fontRef>
+        </p:style>
+        <p:txBody>
+          <a:bodyPr rtlCol="0" anchor="ctr"/>
+          <a:lstStyle/>
+          <a:p>
+            <a:pPr algn="ctr"/>
+            <a:endParaRPr lang="de-DE"/>
+          </a:p>
+        </p:txBody>
+      </p:sp>
+      <p:sp>
+        <p:nvSpPr>
+          <p:cNvPr id="25" name="Pfeil: nach links 24">
+            <a:extLst>
+              <a:ext uri="{FF2B5EF4-FFF2-40B4-BE49-F238E27FC236}">
+                <a16:creationId xmlns:a16="http://schemas.microsoft.com/office/drawing/2014/main" id="{753FC8FE-F56E-45C4-9E72-DDBA99836111}"/>
+              </a:ext>
+            </a:extLst>
+          </p:cNvPr>
+          <p:cNvSpPr/>
+          <p:nvPr/>
+        </p:nvSpPr>
+        <p:spPr>
+          <a:xfrm rot="17749119" flipH="1">
+            <a:off x="3210439" y="2686662"/>
+            <a:ext cx="1065792" cy="317898"/>
+          </a:xfrm>
+          <a:prstGeom prst="leftArrow">
+            <a:avLst/>
+          </a:prstGeom>
+          <a:solidFill>
+            <a:srgbClr val="D6DCE5"/>
+          </a:solidFill>
+          <a:ln>
+            <a:noFill/>
+          </a:ln>
+        </p:spPr>
+        <p:style>
+          <a:lnRef idx="2">
+            <a:schemeClr val="accent1">
+              <a:shade val="50000"/>
+            </a:schemeClr>
+          </a:lnRef>
+          <a:fillRef idx="1">
+            <a:schemeClr val="accent1"/>
+          </a:fillRef>
+          <a:effectRef idx="0">
+            <a:schemeClr val="accent1"/>
+          </a:effectRef>
+          <a:fontRef idx="minor">
+            <a:schemeClr val="lt1"/>
+          </a:fontRef>
+        </p:style>
+        <p:txBody>
+          <a:bodyPr rtlCol="0" anchor="ctr"/>
+          <a:lstStyle/>
+          <a:p>
+            <a:pPr algn="ctr"/>
+            <a:endParaRPr lang="de-DE"/>
+          </a:p>
+        </p:txBody>
+      </p:sp>
+      <p:sp>
+        <p:nvSpPr>
+          <p:cNvPr id="4" name="Rechteck: abgerundete Ecken 3">
+            <a:extLst>
+              <a:ext uri="{FF2B5EF4-FFF2-40B4-BE49-F238E27FC236}">
+                <a16:creationId xmlns:a16="http://schemas.microsoft.com/office/drawing/2014/main" id="{1D19F10A-674D-4908-9A18-FDAD3BD7BEDC}"/>
+              </a:ext>
+            </a:extLst>
+          </p:cNvPr>
+          <p:cNvSpPr/>
+          <p:nvPr/>
+        </p:nvSpPr>
+        <p:spPr>
+          <a:xfrm>
+            <a:off x="1365847" y="2044000"/>
+            <a:ext cx="1676257" cy="318109"/>
+          </a:xfrm>
+          <a:prstGeom prst="roundRect">
+            <a:avLst/>
+          </a:prstGeom>
+          <a:solidFill>
+            <a:srgbClr val="405786"/>
+          </a:solidFill>
+          <a:ln>
+            <a:noFill/>
+          </a:ln>
+        </p:spPr>
+        <p:style>
+          <a:lnRef idx="2">
+            <a:schemeClr val="accent1">
+              <a:shade val="50000"/>
+            </a:schemeClr>
+          </a:lnRef>
+          <a:fillRef idx="1">
+            <a:schemeClr val="accent1"/>
+          </a:fillRef>
+          <a:effectRef idx="0">
+            <a:schemeClr val="accent1"/>
+          </a:effectRef>
+          <a:fontRef idx="minor">
+            <a:schemeClr val="lt1"/>
+          </a:fontRef>
+        </p:style>
+        <p:txBody>
+          <a:bodyPr rtlCol="0" anchor="ctr"/>
+          <a:lstStyle/>
+          <a:p>
+            <a:pPr algn="ctr"/>
+            <a:r>
+              <a:rPr lang="de-DE" sz="1200"/>
+              <a:t>IQB-Studio</a:t>
+            </a:r>
+          </a:p>
+        </p:txBody>
+      </p:sp>
+      <p:sp>
+        <p:nvSpPr>
+          <p:cNvPr id="6" name="Rechteck: abgerundete Ecken 5">
+            <a:extLst>
+              <a:ext uri="{FF2B5EF4-FFF2-40B4-BE49-F238E27FC236}">
+                <a16:creationId xmlns:a16="http://schemas.microsoft.com/office/drawing/2014/main" id="{2B3200A0-8EF8-4FFF-B02C-41172859B333}"/>
+              </a:ext>
+            </a:extLst>
+          </p:cNvPr>
+          <p:cNvSpPr/>
+          <p:nvPr/>
+        </p:nvSpPr>
+        <p:spPr>
+          <a:xfrm>
+            <a:off x="3408092" y="2038168"/>
+            <a:ext cx="1800154" cy="318109"/>
+          </a:xfrm>
+          <a:prstGeom prst="roundRect">
+            <a:avLst/>
+          </a:prstGeom>
+          <a:solidFill>
+            <a:schemeClr val="bg1"/>
+          </a:solidFill>
+          <a:ln>
+            <a:solidFill>
+              <a:schemeClr val="tx1"/>
+            </a:solidFill>
+          </a:ln>
+        </p:spPr>
+        <p:style>
+          <a:lnRef idx="2">
+            <a:schemeClr val="accent1">
+              <a:shade val="50000"/>
+            </a:schemeClr>
+          </a:lnRef>
+          <a:fillRef idx="1">
+            <a:schemeClr val="accent1"/>
+          </a:fillRef>
+          <a:effectRef idx="0">
+            <a:schemeClr val="accent1"/>
+          </a:effectRef>
+          <a:fontRef idx="minor">
+            <a:schemeClr val="lt1"/>
+          </a:fontRef>
+        </p:style>
+        <p:txBody>
+          <a:bodyPr rtlCol="0" anchor="ctr"/>
+          <a:lstStyle/>
+          <a:p>
+            <a:pPr algn="ctr"/>
+            <a:r>
+              <a:rPr lang="de-DE" sz="1200" b="1">
+                <a:solidFill>
+                  <a:schemeClr val="tx1"/>
+                </a:solidFill>
+              </a:rPr>
+              <a:t>Länder-Durchführung</a:t>
+            </a:r>
+          </a:p>
+        </p:txBody>
+      </p:sp>
+      <p:sp>
+        <p:nvSpPr>
+          <p:cNvPr id="13" name="Rechteck 12">
+            <a:extLst>
+              <a:ext uri="{FF2B5EF4-FFF2-40B4-BE49-F238E27FC236}">
+                <a16:creationId xmlns:a16="http://schemas.microsoft.com/office/drawing/2014/main" id="{A96BB776-D63D-43FB-B470-D03AEB0699BD}"/>
+              </a:ext>
+            </a:extLst>
+          </p:cNvPr>
+          <p:cNvSpPr/>
+          <p:nvPr/>
+        </p:nvSpPr>
+        <p:spPr>
+          <a:xfrm>
+            <a:off x="3449000" y="2578246"/>
+            <a:ext cx="1294330" cy="466578"/>
+          </a:xfrm>
+          <a:prstGeom prst="rect">
+            <a:avLst/>
+          </a:prstGeom>
+          <a:noFill/>
+          <a:ln>
+            <a:noFill/>
+          </a:ln>
+        </p:spPr>
+        <p:style>
+          <a:lnRef idx="2">
+            <a:schemeClr val="accent1">
+              <a:shade val="50000"/>
+            </a:schemeClr>
+          </a:lnRef>
+          <a:fillRef idx="1">
+            <a:schemeClr val="accent1"/>
+          </a:fillRef>
+          <a:effectRef idx="0">
+            <a:schemeClr val="accent1"/>
+          </a:effectRef>
+          <a:fontRef idx="minor">
+            <a:schemeClr val="lt1"/>
+          </a:fontRef>
+        </p:style>
+        <p:txBody>
+          <a:bodyPr rtlCol="0" anchor="t"/>
+          <a:lstStyle/>
+          <a:p>
+            <a:pPr algn="ctr"/>
+            <a:r>
+              <a:rPr lang="de-DE" sz="1200">
+                <a:solidFill>
+                  <a:srgbClr val="405786"/>
+                </a:solidFill>
+              </a:rPr>
+              <a:t>Assessment Package</a:t>
+            </a:r>
+          </a:p>
+        </p:txBody>
+      </p:sp>
+      <p:sp>
+        <p:nvSpPr>
+          <p:cNvPr id="29" name="Pfeil: nach rechts 28">
+            <a:extLst>
+              <a:ext uri="{FF2B5EF4-FFF2-40B4-BE49-F238E27FC236}">
+                <a16:creationId xmlns:a16="http://schemas.microsoft.com/office/drawing/2014/main" id="{45D89B47-52C5-4AD1-841B-8C552476B40A}"/>
+              </a:ext>
+            </a:extLst>
+          </p:cNvPr>
+          <p:cNvSpPr/>
+          <p:nvPr/>
+        </p:nvSpPr>
+        <p:spPr>
+          <a:xfrm rot="3850881">
+            <a:off x="2651901" y="4344640"/>
+            <a:ext cx="1819310" cy="317898"/>
+          </a:xfrm>
+          <a:prstGeom prst="rightArrow">
+            <a:avLst/>
+          </a:prstGeom>
+          <a:solidFill>
+            <a:srgbClr val="D6DCE5"/>
+          </a:solidFill>
+          <a:ln>
+            <a:noFill/>
+          </a:ln>
+        </p:spPr>
+        <p:style>
+          <a:lnRef idx="2">
+            <a:schemeClr val="accent1">
+              <a:shade val="50000"/>
+            </a:schemeClr>
+          </a:lnRef>
+          <a:fillRef idx="1">
+            <a:schemeClr val="accent1"/>
+          </a:fillRef>
+          <a:effectRef idx="0">
+            <a:schemeClr val="accent1"/>
+          </a:effectRef>
+          <a:fontRef idx="minor">
+            <a:schemeClr val="lt1"/>
+          </a:fontRef>
+        </p:style>
+        <p:txBody>
+          <a:bodyPr rtlCol="0" anchor="ctr"/>
+          <a:lstStyle/>
+          <a:p>
+            <a:pPr algn="ctr"/>
+            <a:endParaRPr lang="de-DE"/>
+          </a:p>
+        </p:txBody>
+      </p:sp>
+      <p:sp>
+        <p:nvSpPr>
+          <p:cNvPr id="30" name="Pfeil: nach rechts 29">
+            <a:extLst>
+              <a:ext uri="{FF2B5EF4-FFF2-40B4-BE49-F238E27FC236}">
+                <a16:creationId xmlns:a16="http://schemas.microsoft.com/office/drawing/2014/main" id="{E948116F-D3FA-490C-B367-80E0CEF4121F}"/>
+              </a:ext>
+            </a:extLst>
+          </p:cNvPr>
+          <p:cNvSpPr/>
+          <p:nvPr/>
+        </p:nvSpPr>
+        <p:spPr>
+          <a:xfrm rot="17749119" flipH="1">
+            <a:off x="1347880" y="4336905"/>
+            <a:ext cx="1836493" cy="317898"/>
+          </a:xfrm>
+          <a:prstGeom prst="rightArrow">
+            <a:avLst/>
+          </a:prstGeom>
+          <a:solidFill>
+            <a:srgbClr val="D6DCE5"/>
+          </a:solidFill>
+          <a:ln>
+            <a:noFill/>
+          </a:ln>
+        </p:spPr>
+        <p:style>
+          <a:lnRef idx="2">
+            <a:schemeClr val="accent1">
+              <a:shade val="50000"/>
+            </a:schemeClr>
+          </a:lnRef>
+          <a:fillRef idx="1">
+            <a:schemeClr val="accent1"/>
+          </a:fillRef>
+          <a:effectRef idx="0">
+            <a:schemeClr val="accent1"/>
+          </a:effectRef>
+          <a:fontRef idx="minor">
+            <a:schemeClr val="lt1"/>
+          </a:fontRef>
+        </p:style>
+        <p:txBody>
+          <a:bodyPr rtlCol="0" anchor="ctr"/>
+          <a:lstStyle/>
+          <a:p>
+            <a:pPr algn="ctr"/>
+            <a:endParaRPr lang="de-DE"/>
+          </a:p>
+        </p:txBody>
+      </p:sp>
+      <p:sp>
+        <p:nvSpPr>
+          <p:cNvPr id="31" name="Pfeil: nach rechts 30">
+            <a:extLst>
+              <a:ext uri="{FF2B5EF4-FFF2-40B4-BE49-F238E27FC236}">
+                <a16:creationId xmlns:a16="http://schemas.microsoft.com/office/drawing/2014/main" id="{7E1AE68B-0EA4-4E51-B712-345F46C22250}"/>
+              </a:ext>
+            </a:extLst>
+          </p:cNvPr>
+          <p:cNvSpPr/>
+          <p:nvPr/>
+        </p:nvSpPr>
+        <p:spPr>
+          <a:xfrm rot="3850881" flipH="1" flipV="1">
+            <a:off x="4325604" y="3972049"/>
+            <a:ext cx="802022" cy="317898"/>
+          </a:xfrm>
+          <a:prstGeom prst="rightArrow">
+            <a:avLst/>
+          </a:prstGeom>
+          <a:solidFill>
+            <a:srgbClr val="D6DCE5"/>
+          </a:solidFill>
+          <a:ln>
+            <a:noFill/>
+          </a:ln>
+        </p:spPr>
+        <p:style>
+          <a:lnRef idx="2">
+            <a:schemeClr val="accent1">
+              <a:shade val="50000"/>
+            </a:schemeClr>
+          </a:lnRef>
+          <a:fillRef idx="1">
+            <a:schemeClr val="accent1"/>
+          </a:fillRef>
+          <a:effectRef idx="0">
+            <a:schemeClr val="accent1"/>
+          </a:effectRef>
+          <a:fontRef idx="minor">
+            <a:schemeClr val="lt1"/>
+          </a:fontRef>
+        </p:style>
+        <p:txBody>
+          <a:bodyPr rtlCol="0" anchor="ctr"/>
+          <a:lstStyle/>
+          <a:p>
+            <a:pPr algn="ctr"/>
+            <a:endParaRPr lang="de-DE"/>
+          </a:p>
+        </p:txBody>
+      </p:sp>
+      <p:sp>
+        <p:nvSpPr>
+          <p:cNvPr id="32" name="Pfeil: nach rechts 31">
+            <a:extLst>
+              <a:ext uri="{FF2B5EF4-FFF2-40B4-BE49-F238E27FC236}">
+                <a16:creationId xmlns:a16="http://schemas.microsoft.com/office/drawing/2014/main" id="{77EB62EE-B0EB-405E-A9E7-31819D74898A}"/>
+              </a:ext>
+            </a:extLst>
+          </p:cNvPr>
+          <p:cNvSpPr/>
+          <p:nvPr/>
+        </p:nvSpPr>
+        <p:spPr>
+          <a:xfrm rot="17749119" flipV="1">
+            <a:off x="4321033" y="4977845"/>
+            <a:ext cx="844595" cy="317898"/>
+          </a:xfrm>
+          <a:prstGeom prst="rightArrow">
+            <a:avLst/>
+          </a:prstGeom>
+          <a:solidFill>
+            <a:srgbClr val="D6DCE5"/>
+          </a:solidFill>
+          <a:ln>
+            <a:noFill/>
+          </a:ln>
+        </p:spPr>
+        <p:style>
+          <a:lnRef idx="2">
+            <a:schemeClr val="accent1">
+              <a:shade val="50000"/>
+            </a:schemeClr>
+          </a:lnRef>
+          <a:fillRef idx="1">
+            <a:schemeClr val="accent1"/>
+          </a:fillRef>
+          <a:effectRef idx="0">
+            <a:schemeClr val="accent1"/>
+          </a:effectRef>
+          <a:fontRef idx="minor">
+            <a:schemeClr val="lt1"/>
+          </a:fontRef>
+        </p:style>
+        <p:txBody>
+          <a:bodyPr rtlCol="0" anchor="ctr"/>
+          <a:lstStyle/>
+          <a:p>
+            <a:pPr algn="ctr"/>
+            <a:endParaRPr lang="de-DE"/>
+          </a:p>
+        </p:txBody>
+      </p:sp>
+      <p:sp>
+        <p:nvSpPr>
+          <p:cNvPr id="17" name="Rechteck 16">
+            <a:extLst>
+              <a:ext uri="{FF2B5EF4-FFF2-40B4-BE49-F238E27FC236}">
+                <a16:creationId xmlns:a16="http://schemas.microsoft.com/office/drawing/2014/main" id="{BBC0748C-9234-4B45-8D10-CBF7EEE1374C}"/>
+              </a:ext>
+            </a:extLst>
+          </p:cNvPr>
+          <p:cNvSpPr/>
+          <p:nvPr/>
+        </p:nvSpPr>
+        <p:spPr>
+          <a:xfrm>
+            <a:off x="2877192" y="5363651"/>
+            <a:ext cx="866143" cy="275164"/>
+          </a:xfrm>
+          <a:prstGeom prst="rect">
+            <a:avLst/>
+          </a:prstGeom>
+          <a:noFill/>
+          <a:ln>
+            <a:noFill/>
+          </a:ln>
+        </p:spPr>
+        <p:style>
+          <a:lnRef idx="2">
+            <a:schemeClr val="accent1">
+              <a:shade val="50000"/>
+            </a:schemeClr>
+          </a:lnRef>
+          <a:fillRef idx="1">
+            <a:schemeClr val="accent1"/>
+          </a:fillRef>
+          <a:effectRef idx="0">
+            <a:schemeClr val="accent1"/>
+          </a:effectRef>
+          <a:fontRef idx="minor">
+            <a:schemeClr val="lt1"/>
+          </a:fontRef>
+        </p:style>
+        <p:txBody>
+          <a:bodyPr rtlCol="0" anchor="t"/>
+          <a:lstStyle/>
+          <a:p>
+            <a:pPr algn="ctr"/>
+            <a:r>
+              <a:rPr lang="de-DE" sz="1200">
+                <a:solidFill>
+                  <a:srgbClr val="405786"/>
+                </a:solidFill>
+              </a:rPr>
+              <a:t>Antworten</a:t>
+            </a:r>
+            <a:endParaRPr lang="de-DE" sz="1400">
+              <a:solidFill>
+                <a:srgbClr val="405786"/>
+              </a:solidFill>
+            </a:endParaRPr>
+          </a:p>
+        </p:txBody>
+      </p:sp>
+      <p:sp>
+        <p:nvSpPr>
+          <p:cNvPr id="15" name="Rechteck 14">
+            <a:extLst>
+              <a:ext uri="{FF2B5EF4-FFF2-40B4-BE49-F238E27FC236}">
+                <a16:creationId xmlns:a16="http://schemas.microsoft.com/office/drawing/2014/main" id="{A5BFC3D8-81AB-4B6E-AC39-A38E82FEDBCA}"/>
+              </a:ext>
+            </a:extLst>
+          </p:cNvPr>
+          <p:cNvSpPr/>
+          <p:nvPr/>
+        </p:nvSpPr>
+        <p:spPr>
+          <a:xfrm>
+            <a:off x="1489393" y="4134614"/>
+            <a:ext cx="912402" cy="493304"/>
+          </a:xfrm>
+          <a:prstGeom prst="rect">
+            <a:avLst/>
+          </a:prstGeom>
+          <a:noFill/>
+          <a:ln>
+            <a:noFill/>
+          </a:ln>
+        </p:spPr>
+        <p:style>
+          <a:lnRef idx="2">
+            <a:schemeClr val="accent1">
+              <a:shade val="50000"/>
+            </a:schemeClr>
+          </a:lnRef>
+          <a:fillRef idx="1">
+            <a:schemeClr val="accent1"/>
+          </a:fillRef>
+          <a:effectRef idx="0">
+            <a:schemeClr val="accent1"/>
+          </a:effectRef>
+          <a:fontRef idx="minor">
+            <a:schemeClr val="lt1"/>
+          </a:fontRef>
+        </p:style>
+        <p:txBody>
+          <a:bodyPr rtlCol="0" anchor="t"/>
+          <a:lstStyle/>
+          <a:p>
+            <a:pPr algn="ctr"/>
+            <a:r>
+              <a:rPr lang="de-DE" sz="1200">
+                <a:solidFill>
+                  <a:srgbClr val="405786"/>
+                </a:solidFill>
+              </a:rPr>
+              <a:t>Aufgaben, Testhefte</a:t>
+            </a:r>
+            <a:endParaRPr lang="de-DE" sz="1400">
+              <a:solidFill>
+                <a:srgbClr val="405786"/>
+              </a:solidFill>
+            </a:endParaRPr>
+          </a:p>
+        </p:txBody>
+      </p:sp>
+      <p:sp>
+        <p:nvSpPr>
+          <p:cNvPr id="7" name="Rechteck: abgerundete Ecken 6">
+            <a:extLst>
+              <a:ext uri="{FF2B5EF4-FFF2-40B4-BE49-F238E27FC236}">
+                <a16:creationId xmlns:a16="http://schemas.microsoft.com/office/drawing/2014/main" id="{CA9A0AFC-CDCE-4998-A4B7-46F43B78EA44}"/>
+              </a:ext>
+            </a:extLst>
+          </p:cNvPr>
+          <p:cNvSpPr/>
+          <p:nvPr/>
+        </p:nvSpPr>
+        <p:spPr>
+          <a:xfrm>
+            <a:off x="1197445" y="5342179"/>
+            <a:ext cx="1676257" cy="318109"/>
+          </a:xfrm>
+          <a:prstGeom prst="roundRect">
+            <a:avLst/>
+          </a:prstGeom>
+          <a:solidFill>
+            <a:srgbClr val="405786"/>
+          </a:solidFill>
+          <a:ln>
+            <a:noFill/>
+          </a:ln>
+        </p:spPr>
+        <p:style>
+          <a:lnRef idx="2">
+            <a:schemeClr val="accent1">
+              <a:shade val="50000"/>
+            </a:schemeClr>
+          </a:lnRef>
+          <a:fillRef idx="1">
+            <a:schemeClr val="accent1"/>
+          </a:fillRef>
+          <a:effectRef idx="0">
+            <a:schemeClr val="accent1"/>
+          </a:effectRef>
+          <a:fontRef idx="minor">
+            <a:schemeClr val="lt1"/>
+          </a:fontRef>
+        </p:style>
+        <p:txBody>
+          <a:bodyPr rtlCol="0" anchor="ctr"/>
+          <a:lstStyle/>
+          <a:p>
+            <a:pPr algn="ctr"/>
+            <a:r>
+              <a:rPr lang="de-DE" sz="1200"/>
+              <a:t>IQB-Testcenter</a:t>
+            </a:r>
+          </a:p>
+        </p:txBody>
+      </p:sp>
+      <p:sp>
+        <p:nvSpPr>
+          <p:cNvPr id="12" name="Flussdiagramm: Magnetplattenspeicher 11">
+            <a:extLst>
+              <a:ext uri="{FF2B5EF4-FFF2-40B4-BE49-F238E27FC236}">
+                <a16:creationId xmlns:a16="http://schemas.microsoft.com/office/drawing/2014/main" id="{F796BA9E-5480-793C-C4A2-8A734E31A83C}"/>
+              </a:ext>
+            </a:extLst>
+          </p:cNvPr>
+          <p:cNvSpPr/>
+          <p:nvPr/>
+        </p:nvSpPr>
+        <p:spPr>
+          <a:xfrm>
+            <a:off x="5148991" y="5845787"/>
+            <a:ext cx="986740" cy="944880"/>
+          </a:xfrm>
+          <a:prstGeom prst="flowChartMagneticDisk">
+            <a:avLst/>
+          </a:prstGeom>
+          <a:solidFill>
+            <a:schemeClr val="bg1"/>
+          </a:solidFill>
+          <a:ln>
+            <a:solidFill>
+              <a:schemeClr val="tx1"/>
+            </a:solidFill>
+          </a:ln>
+        </p:spPr>
+        <p:style>
+          <a:lnRef idx="2">
+            <a:schemeClr val="accent1">
+              <a:shade val="50000"/>
+            </a:schemeClr>
+          </a:lnRef>
+          <a:fillRef idx="1">
+            <a:schemeClr val="accent1"/>
+          </a:fillRef>
+          <a:effectRef idx="0">
+            <a:schemeClr val="accent1"/>
+          </a:effectRef>
+          <a:fontRef idx="minor">
+            <a:schemeClr val="lt1"/>
+          </a:fontRef>
+        </p:style>
+        <p:txBody>
+          <a:bodyPr rtlCol="0" anchor="ctr"/>
+          <a:lstStyle/>
+          <a:p>
+            <a:pPr algn="ctr"/>
+            <a:r>
+              <a:rPr lang="de-DE" sz="1200" b="1">
+                <a:solidFill>
+                  <a:schemeClr val="tx1"/>
+                </a:solidFill>
+              </a:rPr>
+              <a:t>Daten-Archiv</a:t>
+            </a:r>
+          </a:p>
+        </p:txBody>
+      </p:sp>
+      <p:sp>
+        <p:nvSpPr>
+          <p:cNvPr id="3" name="Pfeil: nach rechts 2">
+            <a:extLst>
+              <a:ext uri="{FF2B5EF4-FFF2-40B4-BE49-F238E27FC236}">
+                <a16:creationId xmlns:a16="http://schemas.microsoft.com/office/drawing/2014/main" id="{1079D243-BA3D-E2A7-7F1D-465FB352B90A}"/>
+              </a:ext>
+            </a:extLst>
+          </p:cNvPr>
+          <p:cNvSpPr/>
+          <p:nvPr/>
+        </p:nvSpPr>
+        <p:spPr>
+          <a:xfrm rot="5400000">
+            <a:off x="4864600" y="5159826"/>
+            <a:ext cx="1555523" cy="317898"/>
+          </a:xfrm>
+          <a:prstGeom prst="rightArrow">
+            <a:avLst/>
+          </a:prstGeom>
+          <a:solidFill>
+            <a:srgbClr val="D6DCE5"/>
+          </a:solidFill>
+          <a:ln>
+            <a:noFill/>
+          </a:ln>
+        </p:spPr>
+        <p:style>
+          <a:lnRef idx="2">
+            <a:schemeClr val="accent1">
+              <a:shade val="50000"/>
+            </a:schemeClr>
+          </a:lnRef>
+          <a:fillRef idx="1">
+            <a:schemeClr val="accent1"/>
+          </a:fillRef>
+          <a:effectRef idx="0">
+            <a:schemeClr val="accent1"/>
+          </a:effectRef>
+          <a:fontRef idx="minor">
+            <a:schemeClr val="lt1"/>
+          </a:fontRef>
+        </p:style>
+        <p:txBody>
+          <a:bodyPr rtlCol="0" anchor="ctr"/>
+          <a:lstStyle/>
+          <a:p>
+            <a:pPr algn="ctr"/>
+            <a:endParaRPr lang="de-DE"/>
+          </a:p>
+        </p:txBody>
+      </p:sp>
+      <p:sp>
+        <p:nvSpPr>
+          <p:cNvPr id="9" name="Rechteck: abgerundete Ecken 8">
+            <a:extLst>
+              <a:ext uri="{FF2B5EF4-FFF2-40B4-BE49-F238E27FC236}">
+                <a16:creationId xmlns:a16="http://schemas.microsoft.com/office/drawing/2014/main" id="{F4BB3833-2C2A-4D03-85C1-B048B97B60EA}"/>
+              </a:ext>
+            </a:extLst>
+          </p:cNvPr>
+          <p:cNvSpPr/>
+          <p:nvPr/>
+        </p:nvSpPr>
+        <p:spPr>
+          <a:xfrm>
+            <a:off x="4674826" y="4420930"/>
+            <a:ext cx="1387562" cy="318109"/>
+          </a:xfrm>
+          <a:prstGeom prst="roundRect">
+            <a:avLst/>
+          </a:prstGeom>
+          <a:solidFill>
+            <a:schemeClr val="bg1"/>
+          </a:solidFill>
+          <a:ln>
+            <a:solidFill>
+              <a:schemeClr val="tx1"/>
+            </a:solidFill>
+          </a:ln>
+        </p:spPr>
+        <p:style>
+          <a:lnRef idx="2">
+            <a:schemeClr val="accent1">
+              <a:shade val="50000"/>
+            </a:schemeClr>
+          </a:lnRef>
+          <a:fillRef idx="1">
+            <a:schemeClr val="accent1"/>
+          </a:fillRef>
+          <a:effectRef idx="0">
+            <a:schemeClr val="accent1"/>
+          </a:effectRef>
+          <a:fontRef idx="minor">
+            <a:schemeClr val="lt1"/>
+          </a:fontRef>
+        </p:style>
+        <p:txBody>
+          <a:bodyPr rtlCol="0" anchor="ctr"/>
+          <a:lstStyle/>
+          <a:p>
+            <a:pPr algn="ctr"/>
+            <a:r>
+              <a:rPr lang="de-DE" sz="1200" b="1">
+                <a:solidFill>
+                  <a:schemeClr val="tx1"/>
+                </a:solidFill>
+              </a:rPr>
+              <a:t>eatTBA</a:t>
+            </a:r>
+          </a:p>
+        </p:txBody>
+      </p:sp>
+      <p:sp>
+        <p:nvSpPr>
+          <p:cNvPr id="14" name="Rechteck 13">
+            <a:extLst>
+              <a:ext uri="{FF2B5EF4-FFF2-40B4-BE49-F238E27FC236}">
+                <a16:creationId xmlns:a16="http://schemas.microsoft.com/office/drawing/2014/main" id="{4BA86029-B693-FD41-5370-C38B7BF743FB}"/>
+              </a:ext>
+            </a:extLst>
+          </p:cNvPr>
+          <p:cNvSpPr/>
+          <p:nvPr/>
+        </p:nvSpPr>
+        <p:spPr>
+          <a:xfrm>
+            <a:off x="4330789" y="4878635"/>
+            <a:ext cx="866143" cy="456162"/>
+          </a:xfrm>
+          <a:prstGeom prst="rect">
+            <a:avLst/>
+          </a:prstGeom>
+          <a:noFill/>
+          <a:ln>
+            <a:noFill/>
+          </a:ln>
+        </p:spPr>
+        <p:style>
+          <a:lnRef idx="2">
+            <a:schemeClr val="accent1">
+              <a:shade val="50000"/>
+            </a:schemeClr>
+          </a:lnRef>
+          <a:fillRef idx="1">
+            <a:schemeClr val="accent1"/>
+          </a:fillRef>
+          <a:effectRef idx="0">
+            <a:schemeClr val="accent1"/>
+          </a:effectRef>
+          <a:fontRef idx="minor">
+            <a:schemeClr val="lt1"/>
+          </a:fontRef>
+        </p:style>
+        <p:txBody>
+          <a:bodyPr rtlCol="0" anchor="t"/>
+          <a:lstStyle/>
+          <a:p>
+            <a:pPr algn="ctr"/>
+            <a:r>
+              <a:rPr lang="de-DE" sz="1200">
+                <a:solidFill>
+                  <a:srgbClr val="405786"/>
+                </a:solidFill>
+              </a:rPr>
+              <a:t>kodierte Antworten</a:t>
+            </a:r>
+            <a:endParaRPr lang="de-DE" sz="1400">
+              <a:solidFill>
+                <a:srgbClr val="405786"/>
+              </a:solidFill>
+            </a:endParaRPr>
+          </a:p>
+        </p:txBody>
+      </p:sp>
+      <p:sp>
+        <p:nvSpPr>
+          <p:cNvPr id="16" name="Rechteck 15">
+            <a:extLst>
+              <a:ext uri="{FF2B5EF4-FFF2-40B4-BE49-F238E27FC236}">
+                <a16:creationId xmlns:a16="http://schemas.microsoft.com/office/drawing/2014/main" id="{B27ED717-A731-F8F3-4893-8FBB71998940}"/>
+              </a:ext>
+            </a:extLst>
+          </p:cNvPr>
+          <p:cNvSpPr/>
+          <p:nvPr/>
+        </p:nvSpPr>
+        <p:spPr>
+          <a:xfrm>
+            <a:off x="5490159" y="4915216"/>
+            <a:ext cx="895401" cy="891224"/>
+          </a:xfrm>
+          <a:prstGeom prst="rect">
+            <a:avLst/>
+          </a:prstGeom>
+          <a:noFill/>
+          <a:ln>
+            <a:noFill/>
+          </a:ln>
+        </p:spPr>
+        <p:style>
+          <a:lnRef idx="2">
+            <a:schemeClr val="accent1">
+              <a:shade val="50000"/>
+            </a:schemeClr>
+          </a:lnRef>
+          <a:fillRef idx="1">
+            <a:schemeClr val="accent1"/>
+          </a:fillRef>
+          <a:effectRef idx="0">
+            <a:schemeClr val="accent1"/>
+          </a:effectRef>
+          <a:fontRef idx="minor">
+            <a:schemeClr val="lt1"/>
+          </a:fontRef>
+        </p:style>
+        <p:txBody>
+          <a:bodyPr rtlCol="0" anchor="t"/>
+          <a:lstStyle/>
+          <a:p>
+            <a:pPr algn="ctr"/>
+            <a:r>
+              <a:rPr lang="de-DE" sz="1200">
+                <a:solidFill>
+                  <a:srgbClr val="405786"/>
+                </a:solidFill>
+              </a:rPr>
+              <a:t>Antworten, Itemdaten,</a:t>
+            </a:r>
+          </a:p>
+          <a:p>
+            <a:pPr algn="ctr"/>
+            <a:r>
+              <a:rPr lang="de-DE" sz="1200">
+                <a:solidFill>
+                  <a:srgbClr val="405786"/>
+                </a:solidFill>
+              </a:rPr>
+              <a:t>Fähigkeits-werte</a:t>
+            </a:r>
+            <a:endParaRPr lang="de-DE" sz="1400">
+              <a:solidFill>
+                <a:srgbClr val="405786"/>
+              </a:solidFill>
+            </a:endParaRPr>
+          </a:p>
+        </p:txBody>
+      </p:sp>
+      <p:sp>
+        <p:nvSpPr>
+          <p:cNvPr id="18" name="Rechteck 17">
+            <a:extLst>
+              <a:ext uri="{FF2B5EF4-FFF2-40B4-BE49-F238E27FC236}">
+                <a16:creationId xmlns:a16="http://schemas.microsoft.com/office/drawing/2014/main" id="{7EFAB975-7544-FB8E-1E76-1F47B4DB4A1E}"/>
+              </a:ext>
+            </a:extLst>
+          </p:cNvPr>
+          <p:cNvSpPr/>
+          <p:nvPr/>
+        </p:nvSpPr>
+        <p:spPr>
+          <a:xfrm>
+            <a:off x="4458697" y="3888327"/>
+            <a:ext cx="866143" cy="456162"/>
+          </a:xfrm>
+          <a:prstGeom prst="rect">
+            <a:avLst/>
+          </a:prstGeom>
+          <a:noFill/>
+          <a:ln>
+            <a:noFill/>
+          </a:ln>
+        </p:spPr>
+        <p:style>
+          <a:lnRef idx="2">
+            <a:schemeClr val="accent1">
+              <a:shade val="50000"/>
+            </a:schemeClr>
+          </a:lnRef>
+          <a:fillRef idx="1">
+            <a:schemeClr val="accent1"/>
+          </a:fillRef>
+          <a:effectRef idx="0">
+            <a:schemeClr val="accent1"/>
+          </a:effectRef>
+          <a:fontRef idx="minor">
+            <a:schemeClr val="lt1"/>
+          </a:fontRef>
+        </p:style>
+        <p:txBody>
+          <a:bodyPr rtlCol="0" anchor="t"/>
+          <a:lstStyle/>
+          <a:p>
+            <a:pPr algn="ctr"/>
+            <a:r>
+              <a:rPr lang="de-DE" sz="1200">
+                <a:solidFill>
+                  <a:srgbClr val="405786"/>
+                </a:solidFill>
+              </a:rPr>
+              <a:t>Item-kennwerte</a:t>
+            </a:r>
+            <a:endParaRPr lang="de-DE" sz="1400">
+              <a:solidFill>
+                <a:srgbClr val="405786"/>
+              </a:solidFill>
+            </a:endParaRPr>
+          </a:p>
+        </p:txBody>
+      </p:sp>
+      <p:sp>
+        <p:nvSpPr>
+          <p:cNvPr id="19" name="Rechteck 18">
+            <a:extLst>
+              <a:ext uri="{FF2B5EF4-FFF2-40B4-BE49-F238E27FC236}">
+                <a16:creationId xmlns:a16="http://schemas.microsoft.com/office/drawing/2014/main" id="{50A89E02-51E0-1E69-76B2-B5EFA4D16E9D}"/>
+              </a:ext>
+            </a:extLst>
+          </p:cNvPr>
+          <p:cNvSpPr/>
+          <p:nvPr/>
+        </p:nvSpPr>
+        <p:spPr>
+          <a:xfrm>
+            <a:off x="2931072" y="4258006"/>
+            <a:ext cx="835184" cy="317898"/>
+          </a:xfrm>
+          <a:prstGeom prst="rect">
+            <a:avLst/>
+          </a:prstGeom>
+          <a:noFill/>
+          <a:ln>
+            <a:noFill/>
+          </a:ln>
+        </p:spPr>
+        <p:style>
+          <a:lnRef idx="2">
+            <a:schemeClr val="accent1">
+              <a:shade val="50000"/>
+            </a:schemeClr>
+          </a:lnRef>
+          <a:fillRef idx="1">
+            <a:schemeClr val="accent1"/>
+          </a:fillRef>
+          <a:effectRef idx="0">
+            <a:schemeClr val="accent1"/>
+          </a:effectRef>
+          <a:fontRef idx="minor">
+            <a:schemeClr val="lt1"/>
+          </a:fontRef>
+        </p:style>
+        <p:txBody>
+          <a:bodyPr rtlCol="0" anchor="t"/>
+          <a:lstStyle/>
+          <a:p>
+            <a:pPr algn="ctr"/>
+            <a:r>
+              <a:rPr lang="de-DE" sz="1200">
+                <a:solidFill>
+                  <a:srgbClr val="405786"/>
+                </a:solidFill>
+              </a:rPr>
+              <a:t>Aufgaben-UI</a:t>
+            </a:r>
+            <a:endParaRPr lang="de-DE" sz="1400">
+              <a:solidFill>
+                <a:srgbClr val="405786"/>
+              </a:solidFill>
+            </a:endParaRPr>
+          </a:p>
+        </p:txBody>
+      </p:sp>
+      <p:sp>
+        <p:nvSpPr>
+          <p:cNvPr id="20" name="Pfeil: nach rechts 19">
+            <a:extLst>
+              <a:ext uri="{FF2B5EF4-FFF2-40B4-BE49-F238E27FC236}">
+                <a16:creationId xmlns:a16="http://schemas.microsoft.com/office/drawing/2014/main" id="{B39DAA76-38F0-1AF7-02A1-8357E9AB6455}"/>
+              </a:ext>
+            </a:extLst>
+          </p:cNvPr>
+          <p:cNvSpPr/>
+          <p:nvPr/>
+        </p:nvSpPr>
+        <p:spPr>
+          <a:xfrm rot="3850881" flipH="1" flipV="1">
+            <a:off x="3013385" y="4500352"/>
+            <a:ext cx="1822517" cy="194103"/>
+          </a:xfrm>
+          <a:prstGeom prst="rightArrow">
+            <a:avLst/>
+          </a:prstGeom>
+          <a:solidFill>
+            <a:srgbClr val="D6DCE5"/>
+          </a:solidFill>
+          <a:ln>
+            <a:noFill/>
+          </a:ln>
+        </p:spPr>
+        <p:style>
+          <a:lnRef idx="2">
+            <a:schemeClr val="accent1">
+              <a:shade val="50000"/>
+            </a:schemeClr>
+          </a:lnRef>
+          <a:fillRef idx="1">
+            <a:schemeClr val="accent1"/>
+          </a:fillRef>
+          <a:effectRef idx="0">
+            <a:schemeClr val="accent1"/>
+          </a:effectRef>
+          <a:fontRef idx="minor">
+            <a:schemeClr val="lt1"/>
+          </a:fontRef>
+        </p:style>
+        <p:txBody>
+          <a:bodyPr rtlCol="0" anchor="ctr"/>
+          <a:lstStyle/>
+          <a:p>
+            <a:pPr algn="ctr"/>
+            <a:endParaRPr lang="de-DE"/>
+          </a:p>
+        </p:txBody>
+      </p:sp>
+      <p:sp>
+        <p:nvSpPr>
+          <p:cNvPr id="23" name="Rechteck 22">
+            <a:extLst>
+              <a:ext uri="{FF2B5EF4-FFF2-40B4-BE49-F238E27FC236}">
+                <a16:creationId xmlns:a16="http://schemas.microsoft.com/office/drawing/2014/main" id="{28E18734-A6B0-4784-F175-872BFD92F14A}"/>
+              </a:ext>
+            </a:extLst>
+          </p:cNvPr>
+          <p:cNvSpPr/>
+          <p:nvPr/>
+        </p:nvSpPr>
+        <p:spPr>
+          <a:xfrm>
+            <a:off x="3381969" y="4578226"/>
+            <a:ext cx="1102995" cy="287136"/>
+          </a:xfrm>
+          <a:prstGeom prst="rect">
+            <a:avLst/>
+          </a:prstGeom>
+          <a:noFill/>
+          <a:ln>
+            <a:noFill/>
+          </a:ln>
+        </p:spPr>
+        <p:style>
+          <a:lnRef idx="2">
+            <a:schemeClr val="accent1">
+              <a:shade val="50000"/>
+            </a:schemeClr>
+          </a:lnRef>
+          <a:fillRef idx="1">
+            <a:schemeClr val="accent1"/>
+          </a:fillRef>
+          <a:effectRef idx="0">
+            <a:schemeClr val="accent1"/>
+          </a:effectRef>
+          <a:fontRef idx="minor">
+            <a:schemeClr val="lt1"/>
+          </a:fontRef>
+        </p:style>
+        <p:txBody>
+          <a:bodyPr rtlCol="0" anchor="t"/>
+          <a:lstStyle/>
+          <a:p>
+            <a:pPr algn="ctr"/>
+            <a:r>
+              <a:rPr lang="de-DE" sz="1200">
+                <a:solidFill>
+                  <a:srgbClr val="405786"/>
+                </a:solidFill>
+              </a:rPr>
+              <a:t>Kodierschema</a:t>
+            </a:r>
+            <a:endParaRPr lang="de-DE" sz="1400">
+              <a:solidFill>
+                <a:srgbClr val="405786"/>
+              </a:solidFill>
+            </a:endParaRPr>
+          </a:p>
+        </p:txBody>
+      </p:sp>
+      <p:sp>
+        <p:nvSpPr>
+          <p:cNvPr id="8" name="Rechteck: abgerundete Ecken 7">
+            <a:extLst>
+              <a:ext uri="{FF2B5EF4-FFF2-40B4-BE49-F238E27FC236}">
+                <a16:creationId xmlns:a16="http://schemas.microsoft.com/office/drawing/2014/main" id="{C650F3AC-0BB7-413D-9A58-24EF66CF2B4F}"/>
+              </a:ext>
+            </a:extLst>
+          </p:cNvPr>
+          <p:cNvSpPr/>
+          <p:nvPr/>
+        </p:nvSpPr>
+        <p:spPr>
+          <a:xfrm>
+            <a:off x="3784333" y="5342179"/>
+            <a:ext cx="1676257" cy="318109"/>
+          </a:xfrm>
+          <a:prstGeom prst="roundRect">
+            <a:avLst/>
+          </a:prstGeom>
+          <a:solidFill>
+            <a:srgbClr val="405786"/>
+          </a:solidFill>
+          <a:ln>
+            <a:noFill/>
+          </a:ln>
+        </p:spPr>
+        <p:style>
+          <a:lnRef idx="2">
+            <a:schemeClr val="accent1">
+              <a:shade val="50000"/>
+            </a:schemeClr>
+          </a:lnRef>
+          <a:fillRef idx="1">
+            <a:schemeClr val="accent1"/>
+          </a:fillRef>
+          <a:effectRef idx="0">
+            <a:schemeClr val="accent1"/>
+          </a:effectRef>
+          <a:fontRef idx="minor">
+            <a:schemeClr val="lt1"/>
+          </a:fontRef>
+        </p:style>
+        <p:txBody>
+          <a:bodyPr rtlCol="0" anchor="ctr"/>
+          <a:lstStyle/>
+          <a:p>
+            <a:pPr algn="ctr"/>
+            <a:r>
+              <a:rPr lang="de-DE" sz="1200"/>
+              <a:t>IQB-KodierBox</a:t>
+            </a:r>
+          </a:p>
+        </p:txBody>
+      </p:sp>
+      <p:sp>
+        <p:nvSpPr>
+          <p:cNvPr id="24" name="Rechteck: abgerundete Ecken 23">
+            <a:extLst>
+              <a:ext uri="{FF2B5EF4-FFF2-40B4-BE49-F238E27FC236}">
+                <a16:creationId xmlns:a16="http://schemas.microsoft.com/office/drawing/2014/main" id="{3773FEF8-5DEB-241E-0E5B-41E0CE987629}"/>
+              </a:ext>
+            </a:extLst>
+          </p:cNvPr>
+          <p:cNvSpPr/>
+          <p:nvPr/>
+        </p:nvSpPr>
+        <p:spPr>
+          <a:xfrm>
+            <a:off x="1627699" y="3228501"/>
+            <a:ext cx="3365128" cy="528923"/>
+          </a:xfrm>
+          <a:prstGeom prst="roundRect">
+            <a:avLst/>
+          </a:prstGeom>
+          <a:solidFill>
+            <a:srgbClr val="405786"/>
+          </a:solidFill>
+          <a:ln>
+            <a:noFill/>
+          </a:ln>
+        </p:spPr>
+        <p:style>
+          <a:lnRef idx="2">
+            <a:schemeClr val="accent1">
+              <a:shade val="50000"/>
+            </a:schemeClr>
+          </a:lnRef>
+          <a:fillRef idx="1">
+            <a:schemeClr val="accent1"/>
+          </a:fillRef>
+          <a:effectRef idx="0">
+            <a:schemeClr val="accent1"/>
+          </a:effectRef>
+          <a:fontRef idx="minor">
+            <a:schemeClr val="lt1"/>
+          </a:fontRef>
+        </p:style>
+        <p:txBody>
+          <a:bodyPr rtlCol="0" anchor="ctr"/>
+          <a:lstStyle/>
+          <a:p>
+            <a:pPr algn="ctr"/>
+            <a:r>
+              <a:rPr lang="de-DE" sz="1600"/>
+              <a:t>IQB-ContentHub</a:t>
+            </a:r>
+          </a:p>
+        </p:txBody>
+      </p:sp>
+    </p:spTree>
+    <p:extLst>
+      <p:ext uri="{BB962C8B-B14F-4D97-AF65-F5344CB8AC3E}">
+        <p14:creationId xmlns:p14="http://schemas.microsoft.com/office/powerpoint/2010/main" val="3370356040"/>
       </p:ext>
     </p:extLst>
   </p:cSld>

</xml_diff>

<commit_message>
Add config in responseAnalyser
</commit_message>
<xml_diff>
--- a/assets/figures.pptx
+++ b/assets/figures.pptx
@@ -253,7 +253,7 @@
           <a:p>
             <a:fld id="{C07B6569-5EFF-41A8-B6CB-39864A9A9501}" type="datetimeFigureOut">
               <a:rPr lang="de-DE" smtClean="0"/>
-              <a:t>26.09.2026</a:t>
+              <a:t>27.09.2026</a:t>
             </a:fld>
             <a:endParaRPr lang="de-DE"/>
           </a:p>
@@ -423,7 +423,7 @@
           <a:p>
             <a:fld id="{C07B6569-5EFF-41A8-B6CB-39864A9A9501}" type="datetimeFigureOut">
               <a:rPr lang="de-DE" smtClean="0"/>
-              <a:t>26.09.2026</a:t>
+              <a:t>27.09.2026</a:t>
             </a:fld>
             <a:endParaRPr lang="de-DE"/>
           </a:p>
@@ -603,7 +603,7 @@
           <a:p>
             <a:fld id="{C07B6569-5EFF-41A8-B6CB-39864A9A9501}" type="datetimeFigureOut">
               <a:rPr lang="de-DE" smtClean="0"/>
-              <a:t>26.09.2026</a:t>
+              <a:t>27.09.2026</a:t>
             </a:fld>
             <a:endParaRPr lang="de-DE"/>
           </a:p>
@@ -850,7 +850,7 @@
           <a:p>
             <a:fld id="{C07B6569-5EFF-41A8-B6CB-39864A9A9501}" type="datetimeFigureOut">
               <a:rPr lang="de-DE" smtClean="0"/>
-              <a:t>26.09.2026</a:t>
+              <a:t>27.09.2026</a:t>
             </a:fld>
             <a:endParaRPr lang="de-DE"/>
           </a:p>
@@ -1094,7 +1094,7 @@
           <a:p>
             <a:fld id="{C07B6569-5EFF-41A8-B6CB-39864A9A9501}" type="datetimeFigureOut">
               <a:rPr lang="de-DE" smtClean="0"/>
-              <a:t>26.09.2026</a:t>
+              <a:t>27.09.2026</a:t>
             </a:fld>
             <a:endParaRPr lang="de-DE"/>
           </a:p>
@@ -1326,7 +1326,7 @@
           <a:p>
             <a:fld id="{C07B6569-5EFF-41A8-B6CB-39864A9A9501}" type="datetimeFigureOut">
               <a:rPr lang="de-DE" smtClean="0"/>
-              <a:t>26.09.2026</a:t>
+              <a:t>27.09.2026</a:t>
             </a:fld>
             <a:endParaRPr lang="de-DE"/>
           </a:p>
@@ -1693,7 +1693,7 @@
           <a:p>
             <a:fld id="{C07B6569-5EFF-41A8-B6CB-39864A9A9501}" type="datetimeFigureOut">
               <a:rPr lang="de-DE" smtClean="0"/>
-              <a:t>26.09.2026</a:t>
+              <a:t>27.09.2026</a:t>
             </a:fld>
             <a:endParaRPr lang="de-DE"/>
           </a:p>
@@ -1811,7 +1811,7 @@
           <a:p>
             <a:fld id="{C07B6569-5EFF-41A8-B6CB-39864A9A9501}" type="datetimeFigureOut">
               <a:rPr lang="de-DE" smtClean="0"/>
-              <a:t>26.09.2026</a:t>
+              <a:t>27.09.2026</a:t>
             </a:fld>
             <a:endParaRPr lang="de-DE"/>
           </a:p>
@@ -1906,7 +1906,7 @@
           <a:p>
             <a:fld id="{C07B6569-5EFF-41A8-B6CB-39864A9A9501}" type="datetimeFigureOut">
               <a:rPr lang="de-DE" smtClean="0"/>
-              <a:t>26.09.2026</a:t>
+              <a:t>27.09.2026</a:t>
             </a:fld>
             <a:endParaRPr lang="de-DE"/>
           </a:p>
@@ -2183,7 +2183,7 @@
           <a:p>
             <a:fld id="{C07B6569-5EFF-41A8-B6CB-39864A9A9501}" type="datetimeFigureOut">
               <a:rPr lang="de-DE" smtClean="0"/>
-              <a:t>26.09.2026</a:t>
+              <a:t>27.09.2026</a:t>
             </a:fld>
             <a:endParaRPr lang="de-DE"/>
           </a:p>
@@ -2440,7 +2440,7 @@
           <a:p>
             <a:fld id="{C07B6569-5EFF-41A8-B6CB-39864A9A9501}" type="datetimeFigureOut">
               <a:rPr lang="de-DE" smtClean="0"/>
-              <a:t>26.09.2026</a:t>
+              <a:t>27.09.2026</a:t>
             </a:fld>
             <a:endParaRPr lang="de-DE"/>
           </a:p>
@@ -2653,7 +2653,7 @@
           <a:p>
             <a:fld id="{C07B6569-5EFF-41A8-B6CB-39864A9A9501}" type="datetimeFigureOut">
               <a:rPr lang="de-DE" smtClean="0"/>
-              <a:t>26.09.2026</a:t>
+              <a:t>27.09.2026</a:t>
             </a:fld>
             <a:endParaRPr lang="de-DE"/>
           </a:p>
@@ -11488,8 +11488,8 @@
         </p:nvSpPr>
         <p:spPr>
           <a:xfrm>
-            <a:off x="1537998" y="3572600"/>
-            <a:ext cx="1223762" cy="424133"/>
+            <a:off x="1462043" y="3572600"/>
+            <a:ext cx="1299717" cy="424133"/>
           </a:xfrm>
           <a:prstGeom prst="homePlate">
             <a:avLst/>
@@ -11534,6 +11534,164 @@
               <a:t>Item-Liste</a:t>
             </a:r>
           </a:p>
+        </p:txBody>
+      </p:sp>
+      <p:sp>
+        <p:nvSpPr>
+          <p:cNvPr id="45" name="Rechteck: abgerundete Ecken 44">
+            <a:extLst>
+              <a:ext uri="{FF2B5EF4-FFF2-40B4-BE49-F238E27FC236}">
+                <a16:creationId xmlns:a16="http://schemas.microsoft.com/office/drawing/2014/main" id="{123DEF27-8C5E-4BD9-8566-7C089C43D140}"/>
+              </a:ext>
+            </a:extLst>
+          </p:cNvPr>
+          <p:cNvSpPr/>
+          <p:nvPr/>
+        </p:nvSpPr>
+        <p:spPr>
+          <a:xfrm>
+            <a:off x="2782421" y="4654787"/>
+            <a:ext cx="1575297" cy="848266"/>
+          </a:xfrm>
+          <a:prstGeom prst="roundRect">
+            <a:avLst/>
+          </a:prstGeom>
+          <a:solidFill>
+            <a:srgbClr val="405786"/>
+          </a:solidFill>
+          <a:ln>
+            <a:noFill/>
+          </a:ln>
+        </p:spPr>
+        <p:style>
+          <a:lnRef idx="2">
+            <a:schemeClr val="accent1">
+              <a:shade val="50000"/>
+            </a:schemeClr>
+          </a:lnRef>
+          <a:fillRef idx="1">
+            <a:schemeClr val="accent1"/>
+          </a:fillRef>
+          <a:effectRef idx="0">
+            <a:schemeClr val="accent1"/>
+          </a:effectRef>
+          <a:fontRef idx="minor">
+            <a:schemeClr val="lt1"/>
+          </a:fontRef>
+        </p:style>
+        <p:txBody>
+          <a:bodyPr rtlCol="0" anchor="ctr"/>
+          <a:lstStyle/>
+          <a:p>
+            <a:pPr algn="ctr"/>
+            <a:r>
+              <a:rPr lang="de-DE" sz="1200"/>
+              <a:t>Skalierung</a:t>
+            </a:r>
+          </a:p>
+        </p:txBody>
+      </p:sp>
+      <p:sp>
+        <p:nvSpPr>
+          <p:cNvPr id="46" name="Flussdiagramm: Verbinder zu einer anderen Seite 45">
+            <a:extLst>
+              <a:ext uri="{FF2B5EF4-FFF2-40B4-BE49-F238E27FC236}">
+                <a16:creationId xmlns:a16="http://schemas.microsoft.com/office/drawing/2014/main" id="{ACAFB794-65DC-47D5-9F93-BA7CB2D3CD86}"/>
+              </a:ext>
+            </a:extLst>
+          </p:cNvPr>
+          <p:cNvSpPr/>
+          <p:nvPr/>
+        </p:nvSpPr>
+        <p:spPr>
+          <a:xfrm>
+            <a:off x="3124935" y="5503052"/>
+            <a:ext cx="890268" cy="577545"/>
+          </a:xfrm>
+          <a:prstGeom prst="flowChartOffpageConnector">
+            <a:avLst/>
+          </a:prstGeom>
+          <a:solidFill>
+            <a:srgbClr val="008CBA"/>
+          </a:solidFill>
+          <a:ln>
+            <a:noFill/>
+          </a:ln>
+        </p:spPr>
+        <p:style>
+          <a:lnRef idx="2">
+            <a:schemeClr val="accent1">
+              <a:shade val="50000"/>
+            </a:schemeClr>
+          </a:lnRef>
+          <a:fillRef idx="1">
+            <a:schemeClr val="accent1"/>
+          </a:fillRef>
+          <a:effectRef idx="0">
+            <a:schemeClr val="accent1"/>
+          </a:effectRef>
+          <a:fontRef idx="minor">
+            <a:schemeClr val="lt1"/>
+          </a:fontRef>
+        </p:style>
+        <p:txBody>
+          <a:bodyPr lIns="0" tIns="0" rIns="0" bIns="0" rtlCol="0" anchor="ctr"/>
+          <a:lstStyle/>
+          <a:p>
+            <a:pPr algn="ctr"/>
+            <a:r>
+              <a:rPr lang="de-DE" sz="1200"/>
+              <a:t>Skill-Set</a:t>
+            </a:r>
+          </a:p>
+        </p:txBody>
+      </p:sp>
+      <p:sp>
+        <p:nvSpPr>
+          <p:cNvPr id="50" name="Pfeil: Fünfeck 49">
+            <a:extLst>
+              <a:ext uri="{FF2B5EF4-FFF2-40B4-BE49-F238E27FC236}">
+                <a16:creationId xmlns:a16="http://schemas.microsoft.com/office/drawing/2014/main" id="{D9D09B6D-6308-49E1-AEAB-9987904C5A95}"/>
+              </a:ext>
+            </a:extLst>
+          </p:cNvPr>
+          <p:cNvSpPr/>
+          <p:nvPr/>
+        </p:nvSpPr>
+        <p:spPr>
+          <a:xfrm>
+            <a:off x="1463040" y="2490414"/>
+            <a:ext cx="1299717" cy="424133"/>
+          </a:xfrm>
+          <a:prstGeom prst="homePlate">
+            <a:avLst/>
+          </a:prstGeom>
+          <a:solidFill>
+            <a:srgbClr val="D6DCE5"/>
+          </a:solidFill>
+          <a:ln>
+            <a:noFill/>
+          </a:ln>
+        </p:spPr>
+        <p:style>
+          <a:lnRef idx="2">
+            <a:schemeClr val="accent1">
+              <a:shade val="50000"/>
+            </a:schemeClr>
+          </a:lnRef>
+          <a:fillRef idx="1">
+            <a:schemeClr val="accent1"/>
+          </a:fillRef>
+          <a:effectRef idx="0">
+            <a:schemeClr val="accent1"/>
+          </a:effectRef>
+          <a:fontRef idx="minor">
+            <a:schemeClr val="lt1"/>
+          </a:fontRef>
+        </p:style>
+        <p:txBody>
+          <a:bodyPr rtlCol="0" anchor="ctr"/>
+          <a:lstStyle/>
           <a:p>
             <a:pPr marL="171450" indent="-171450">
               <a:buFont typeface="Arial" panose="020B0604020202020204" pitchFamily="34" charset="0"/>
@@ -11545,167 +11703,9 @@
                   <a:schemeClr val="tx1"/>
                 </a:solidFill>
               </a:rPr>
-              <a:t>Missing-Map</a:t>
-            </a:r>
-          </a:p>
-        </p:txBody>
-      </p:sp>
-      <p:sp>
-        <p:nvSpPr>
-          <p:cNvPr id="45" name="Rechteck: abgerundete Ecken 44">
-            <a:extLst>
-              <a:ext uri="{FF2B5EF4-FFF2-40B4-BE49-F238E27FC236}">
-                <a16:creationId xmlns:a16="http://schemas.microsoft.com/office/drawing/2014/main" id="{123DEF27-8C5E-4BD9-8566-7C089C43D140}"/>
-              </a:ext>
-            </a:extLst>
-          </p:cNvPr>
-          <p:cNvSpPr/>
-          <p:nvPr/>
-        </p:nvSpPr>
-        <p:spPr>
-          <a:xfrm>
-            <a:off x="2782421" y="4654787"/>
-            <a:ext cx="1575297" cy="848266"/>
-          </a:xfrm>
-          <a:prstGeom prst="roundRect">
-            <a:avLst/>
-          </a:prstGeom>
-          <a:solidFill>
-            <a:srgbClr val="405786"/>
-          </a:solidFill>
-          <a:ln>
-            <a:noFill/>
-          </a:ln>
-        </p:spPr>
-        <p:style>
-          <a:lnRef idx="2">
-            <a:schemeClr val="accent1">
-              <a:shade val="50000"/>
-            </a:schemeClr>
-          </a:lnRef>
-          <a:fillRef idx="1">
-            <a:schemeClr val="accent1"/>
-          </a:fillRef>
-          <a:effectRef idx="0">
-            <a:schemeClr val="accent1"/>
-          </a:effectRef>
-          <a:fontRef idx="minor">
-            <a:schemeClr val="lt1"/>
-          </a:fontRef>
-        </p:style>
-        <p:txBody>
-          <a:bodyPr rtlCol="0" anchor="ctr"/>
-          <a:lstStyle/>
-          <a:p>
-            <a:pPr algn="ctr"/>
-            <a:r>
-              <a:rPr lang="de-DE" sz="1200"/>
-              <a:t>Skalierung</a:t>
-            </a:r>
-          </a:p>
-        </p:txBody>
-      </p:sp>
-      <p:sp>
-        <p:nvSpPr>
-          <p:cNvPr id="46" name="Flussdiagramm: Verbinder zu einer anderen Seite 45">
-            <a:extLst>
-              <a:ext uri="{FF2B5EF4-FFF2-40B4-BE49-F238E27FC236}">
-                <a16:creationId xmlns:a16="http://schemas.microsoft.com/office/drawing/2014/main" id="{ACAFB794-65DC-47D5-9F93-BA7CB2D3CD86}"/>
-              </a:ext>
-            </a:extLst>
-          </p:cNvPr>
-          <p:cNvSpPr/>
-          <p:nvPr/>
-        </p:nvSpPr>
-        <p:spPr>
-          <a:xfrm>
-            <a:off x="3124935" y="5503052"/>
-            <a:ext cx="890268" cy="577545"/>
-          </a:xfrm>
-          <a:prstGeom prst="flowChartOffpageConnector">
-            <a:avLst/>
-          </a:prstGeom>
-          <a:solidFill>
-            <a:srgbClr val="008CBA"/>
-          </a:solidFill>
-          <a:ln>
-            <a:noFill/>
-          </a:ln>
-        </p:spPr>
-        <p:style>
-          <a:lnRef idx="2">
-            <a:schemeClr val="accent1">
-              <a:shade val="50000"/>
-            </a:schemeClr>
-          </a:lnRef>
-          <a:fillRef idx="1">
-            <a:schemeClr val="accent1"/>
-          </a:fillRef>
-          <a:effectRef idx="0">
-            <a:schemeClr val="accent1"/>
-          </a:effectRef>
-          <a:fontRef idx="minor">
-            <a:schemeClr val="lt1"/>
-          </a:fontRef>
-        </p:style>
-        <p:txBody>
-          <a:bodyPr lIns="0" tIns="0" rIns="0" bIns="0" rtlCol="0" anchor="ctr"/>
-          <a:lstStyle/>
-          <a:p>
-            <a:pPr algn="ctr"/>
-            <a:r>
-              <a:rPr lang="de-DE" sz="1200"/>
-              <a:t>Skill-Set</a:t>
-            </a:r>
-          </a:p>
-        </p:txBody>
-      </p:sp>
-      <p:sp>
-        <p:nvSpPr>
-          <p:cNvPr id="50" name="Pfeil: Fünfeck 49">
-            <a:extLst>
-              <a:ext uri="{FF2B5EF4-FFF2-40B4-BE49-F238E27FC236}">
-                <a16:creationId xmlns:a16="http://schemas.microsoft.com/office/drawing/2014/main" id="{D9D09B6D-6308-49E1-AEAB-9987904C5A95}"/>
-              </a:ext>
-            </a:extLst>
-          </p:cNvPr>
-          <p:cNvSpPr/>
-          <p:nvPr/>
-        </p:nvSpPr>
-        <p:spPr>
-          <a:xfrm>
-            <a:off x="1538995" y="2490414"/>
-            <a:ext cx="1223762" cy="424133"/>
-          </a:xfrm>
-          <a:prstGeom prst="homePlate">
-            <a:avLst/>
-          </a:prstGeom>
-          <a:solidFill>
-            <a:srgbClr val="D6DCE5"/>
-          </a:solidFill>
-          <a:ln>
-            <a:noFill/>
-          </a:ln>
-        </p:spPr>
-        <p:style>
-          <a:lnRef idx="2">
-            <a:schemeClr val="accent1">
-              <a:shade val="50000"/>
-            </a:schemeClr>
-          </a:lnRef>
-          <a:fillRef idx="1">
-            <a:schemeClr val="accent1"/>
-          </a:fillRef>
-          <a:effectRef idx="0">
-            <a:schemeClr val="accent1"/>
-          </a:effectRef>
-          <a:fontRef idx="minor">
-            <a:schemeClr val="lt1"/>
-          </a:fontRef>
-        </p:style>
-        <p:txBody>
-          <a:bodyPr rtlCol="0" anchor="ctr"/>
-          <a:lstStyle/>
+              <a:t>Kodierschema</a:t>
+            </a:r>
+          </a:p>
           <a:p>
             <a:pPr marL="171450" indent="-171450">
               <a:buFont typeface="Arial" panose="020B0604020202020204" pitchFamily="34" charset="0"/>
@@ -11717,7 +11717,7 @@
                   <a:schemeClr val="tx1"/>
                 </a:solidFill>
               </a:rPr>
-              <a:t>Kodier-schema</a:t>
+              <a:t>Konfiguration</a:t>
             </a:r>
           </a:p>
         </p:txBody>
@@ -11736,8 +11736,8 @@
         </p:nvSpPr>
         <p:spPr>
           <a:xfrm>
-            <a:off x="1537998" y="4654786"/>
-            <a:ext cx="1220492" cy="424133"/>
+            <a:off x="1458773" y="4654786"/>
+            <a:ext cx="1299717" cy="424133"/>
           </a:xfrm>
           <a:prstGeom prst="homePlate">
             <a:avLst/>
@@ -11798,8 +11798,8 @@
         </p:nvSpPr>
         <p:spPr>
           <a:xfrm>
-            <a:off x="1537998" y="5078919"/>
-            <a:ext cx="1223762" cy="424133"/>
+            <a:off x="1458773" y="5078919"/>
+            <a:ext cx="1302987" cy="424133"/>
           </a:xfrm>
           <a:prstGeom prst="homePlate">
             <a:avLst/>

</xml_diff>